<commit_message>
Remove framework choices from the four-person topic deck.
Topics stay in easiest-first order, and each row now shows only the difficulty and the four roles.

Co-authored-by: KangMin <destiny54155415@users.noreply.github.com>
</commit_message>
<xml_diff>
--- a/docs/B2C-4인-쉬운순-주제10.pptx
+++ b/docs/B2C-4인-쉬운순-주제10.pptx
@@ -7177,7 +7177,7 @@
         <p:spPr>
           <a:xfrm>
             <a:off x="1325880" y="1280160"/>
-            <a:ext cx="6035040" cy="347472"/>
+            <a:ext cx="7680960" cy="347472"/>
           </a:xfrm>
           <a:prstGeom prst="rect">
             <a:avLst/>
@@ -7218,8 +7218,50 @@
         </p:nvSpPr>
         <p:spPr>
           <a:xfrm>
+            <a:off x="9418320" y="1280160"/>
+            <a:ext cx="2057400" cy="347472"/>
+          </a:xfrm>
+          <a:prstGeom prst="rect">
+            <a:avLst/>
+          </a:prstGeom>
+          <a:noFill/>
+        </p:spPr>
+        <p:txBody>
+          <a:bodyPr wrap="square" anchor="ctr"/>
+          <a:lstStyle/>
+          <a:p>
+            <a:pPr algn="r">
+              <a:spcBef>
+                <a:spcPts val="0"/>
+              </a:spcBef>
+              <a:spcAft>
+                <a:spcPts val="0"/>
+              </a:spcAft>
+            </a:pPr>
+            <a:r>
+              <a:rPr sz="1400" b="1" i="0">
+                <a:solidFill>
+                  <a:srgbClr val="1C6B64"/>
+                </a:solidFill>
+                <a:latin typeface="Malgun Gothic"/>
+                <a:ea typeface="Malgun Gothic"/>
+                <a:cs typeface="Malgun Gothic"/>
+              </a:rPr>
+              <a:t>쉬움</a:t>
+            </a:r>
+          </a:p>
+        </p:txBody>
+      </p:sp>
+      <p:sp>
+        <p:nvSpPr>
+          <p:cNvPr id="11" name="TextBox 10"/>
+          <p:cNvSpPr txBox="1"/>
+          <p:nvPr/>
+        </p:nvSpPr>
+        <p:spPr>
+          <a:xfrm>
             <a:off x="1325880" y="1609344"/>
-            <a:ext cx="7589520" cy="256032"/>
+            <a:ext cx="10058400" cy="256032"/>
           </a:xfrm>
           <a:prstGeom prst="rect">
             <a:avLst/>
@@ -7254,14 +7296,14 @@
       </p:sp>
       <p:sp>
         <p:nvSpPr>
-          <p:cNvPr id="11" name="TextBox 10"/>
+          <p:cNvPr id="12" name="TextBox 11"/>
           <p:cNvSpPr txBox="1"/>
           <p:nvPr/>
         </p:nvSpPr>
         <p:spPr>
           <a:xfrm>
             <a:off x="1325880" y="1847088"/>
-            <a:ext cx="7772400" cy="256032"/>
+            <a:ext cx="10058400" cy="256032"/>
           </a:xfrm>
           <a:prstGeom prst="rect">
             <a:avLst/>
@@ -7296,94 +7338,7 @@
       </p:sp>
       <p:sp>
         <p:nvSpPr>
-          <p:cNvPr id="12" name="Rounded Rectangle 11"/>
-          <p:cNvSpPr/>
-          <p:nvPr/>
-        </p:nvSpPr>
-        <p:spPr>
-          <a:xfrm>
-            <a:off x="10195560" y="1481328"/>
-            <a:ext cx="1298448" cy="384048"/>
-          </a:xfrm>
-          <a:prstGeom prst="roundRect">
-            <a:avLst>
-              <a:gd name="adj" fmla="val 40000"/>
-            </a:avLst>
-          </a:prstGeom>
-          <a:solidFill>
-            <a:srgbClr val="1C6B64"/>
-          </a:solidFill>
-          <a:ln>
-            <a:noFill/>
-          </a:ln>
-        </p:spPr>
-        <p:style>
-          <a:lnRef idx="1">
-            <a:schemeClr val="accent1"/>
-          </a:lnRef>
-          <a:fillRef idx="3">
-            <a:schemeClr val="accent1"/>
-          </a:fillRef>
-          <a:effectRef idx="2">
-            <a:schemeClr val="accent1"/>
-          </a:effectRef>
-          <a:fontRef idx="minor">
-            <a:schemeClr val="lt1"/>
-          </a:fontRef>
-        </p:style>
-        <p:txBody>
-          <a:bodyPr rtlCol="0" anchor="ctr"/>
-          <a:lstStyle/>
-          <a:p>
-            <a:pPr algn="ctr"/>
-          </a:p>
-        </p:txBody>
-      </p:sp>
-      <p:sp>
-        <p:nvSpPr>
-          <p:cNvPr id="13" name="TextBox 12"/>
-          <p:cNvSpPr txBox="1"/>
-          <p:nvPr/>
-        </p:nvSpPr>
-        <p:spPr>
-          <a:xfrm>
-            <a:off x="10195560" y="1481328"/>
-            <a:ext cx="1298448" cy="384048"/>
-          </a:xfrm>
-          <a:prstGeom prst="rect">
-            <a:avLst/>
-          </a:prstGeom>
-          <a:noFill/>
-        </p:spPr>
-        <p:txBody>
-          <a:bodyPr wrap="square" anchor="ctr"/>
-          <a:lstStyle/>
-          <a:p>
-            <a:pPr algn="ctr">
-              <a:spcBef>
-                <a:spcPts val="0"/>
-              </a:spcBef>
-              <a:spcAft>
-                <a:spcPts val="0"/>
-              </a:spcAft>
-            </a:pPr>
-            <a:r>
-              <a:rPr sz="1300" b="1" i="0">
-                <a:solidFill>
-                  <a:srgbClr val="FFFFFF"/>
-                </a:solidFill>
-                <a:latin typeface="Malgun Gothic"/>
-                <a:ea typeface="Malgun Gothic"/>
-                <a:cs typeface="Malgun Gothic"/>
-              </a:rPr>
-              <a:t>MyBatis</a:t>
-            </a:r>
-          </a:p>
-        </p:txBody>
-      </p:sp>
-      <p:sp>
-        <p:nvSpPr>
-          <p:cNvPr id="14" name="Rounded Rectangle 13"/>
+          <p:cNvPr id="13" name="Rounded Rectangle 12"/>
           <p:cNvSpPr/>
           <p:nvPr/>
         </p:nvSpPr>
@@ -7430,7 +7385,7 @@
       </p:sp>
       <p:sp>
         <p:nvSpPr>
-          <p:cNvPr id="15" name="Rectangle 14"/>
+          <p:cNvPr id="14" name="Rectangle 13"/>
           <p:cNvSpPr/>
           <p:nvPr/>
         </p:nvSpPr>
@@ -7473,7 +7428,7 @@
       </p:sp>
       <p:sp>
         <p:nvSpPr>
-          <p:cNvPr id="16" name="TextBox 15"/>
+          <p:cNvPr id="15" name="TextBox 14"/>
           <p:cNvSpPr txBox="1"/>
           <p:nvPr/>
         </p:nvSpPr>
@@ -7515,14 +7470,56 @@
       </p:sp>
       <p:sp>
         <p:nvSpPr>
+          <p:cNvPr id="16" name="TextBox 15"/>
+          <p:cNvSpPr txBox="1"/>
+          <p:nvPr/>
+        </p:nvSpPr>
+        <p:spPr>
+          <a:xfrm>
+            <a:off x="1325880" y="2322576"/>
+            <a:ext cx="7680960" cy="347472"/>
+          </a:xfrm>
+          <a:prstGeom prst="rect">
+            <a:avLst/>
+          </a:prstGeom>
+          <a:noFill/>
+        </p:spPr>
+        <p:txBody>
+          <a:bodyPr wrap="square" anchor="ctr"/>
+          <a:lstStyle/>
+          <a:p>
+            <a:pPr algn="l">
+              <a:spcBef>
+                <a:spcPts val="0"/>
+              </a:spcBef>
+              <a:spcAft>
+                <a:spcPts val="0"/>
+              </a:spcAft>
+            </a:pPr>
+            <a:r>
+              <a:rPr sz="2000" b="1" i="0">
+                <a:solidFill>
+                  <a:srgbClr val="1B2E3C"/>
+                </a:solidFill>
+                <a:latin typeface="Malgun Gothic"/>
+                <a:ea typeface="Malgun Gothic"/>
+                <a:cs typeface="Malgun Gothic"/>
+              </a:rPr>
+              <a:t>원데이 클래스</a:t>
+            </a:r>
+          </a:p>
+        </p:txBody>
+      </p:sp>
+      <p:sp>
+        <p:nvSpPr>
           <p:cNvPr id="17" name="TextBox 16"/>
           <p:cNvSpPr txBox="1"/>
           <p:nvPr/>
         </p:nvSpPr>
         <p:spPr>
           <a:xfrm>
-            <a:off x="1325880" y="2322576"/>
-            <a:ext cx="6035040" cy="347472"/>
+            <a:off x="9418320" y="2322576"/>
+            <a:ext cx="2057400" cy="347472"/>
           </a:xfrm>
           <a:prstGeom prst="rect">
             <a:avLst/>
@@ -7533,6 +7530,48 @@
           <a:bodyPr wrap="square" anchor="ctr"/>
           <a:lstStyle/>
           <a:p>
+            <a:pPr algn="r">
+              <a:spcBef>
+                <a:spcPts val="0"/>
+              </a:spcBef>
+              <a:spcAft>
+                <a:spcPts val="0"/>
+              </a:spcAft>
+            </a:pPr>
+            <a:r>
+              <a:rPr sz="1400" b="1" i="0">
+                <a:solidFill>
+                  <a:srgbClr val="1C6B64"/>
+                </a:solidFill>
+                <a:latin typeface="Malgun Gothic"/>
+                <a:ea typeface="Malgun Gothic"/>
+                <a:cs typeface="Malgun Gothic"/>
+              </a:rPr>
+              <a:t>쉬움</a:t>
+            </a:r>
+          </a:p>
+        </p:txBody>
+      </p:sp>
+      <p:sp>
+        <p:nvSpPr>
+          <p:cNvPr id="18" name="TextBox 17"/>
+          <p:cNvSpPr txBox="1"/>
+          <p:nvPr/>
+        </p:nvSpPr>
+        <p:spPr>
+          <a:xfrm>
+            <a:off x="1325880" y="2651760"/>
+            <a:ext cx="10058400" cy="256032"/>
+          </a:xfrm>
+          <a:prstGeom prst="rect">
+            <a:avLst/>
+          </a:prstGeom>
+          <a:noFill/>
+        </p:spPr>
+        <p:txBody>
+          <a:bodyPr wrap="square" anchor="ctr"/>
+          <a:lstStyle/>
+          <a:p>
             <a:pPr algn="l">
               <a:spcBef>
                 <a:spcPts val="0"/>
@@ -7542,29 +7581,29 @@
               </a:spcAft>
             </a:pPr>
             <a:r>
-              <a:rPr sz="2000" b="1" i="0">
-                <a:solidFill>
-                  <a:srgbClr val="1B2E3C"/>
-                </a:solidFill>
-                <a:latin typeface="Malgun Gothic"/>
-                <a:ea typeface="Malgun Gothic"/>
-                <a:cs typeface="Malgun Gothic"/>
-              </a:rPr>
-              <a:t>원데이 클래스</a:t>
-            </a:r>
-          </a:p>
-        </p:txBody>
-      </p:sp>
-      <p:sp>
-        <p:nvSpPr>
-          <p:cNvPr id="18" name="TextBox 17"/>
-          <p:cNvSpPr txBox="1"/>
-          <p:nvPr/>
-        </p:nvSpPr>
-        <p:spPr>
-          <a:xfrm>
-            <a:off x="1325880" y="2651760"/>
-            <a:ext cx="7589520" cy="256032"/>
+              <a:rPr sz="1300" b="0" i="0">
+                <a:solidFill>
+                  <a:srgbClr val="1C2830"/>
+                </a:solidFill>
+                <a:latin typeface="Malgun Gothic"/>
+                <a:ea typeface="Malgun Gothic"/>
+                <a:cs typeface="Malgun Gothic"/>
+              </a:rPr>
+              <a:t>회차를 고르고, 정원만 넘지 않게 받습니다.</a:t>
+            </a:r>
+          </a:p>
+        </p:txBody>
+      </p:sp>
+      <p:sp>
+        <p:nvSpPr>
+          <p:cNvPr id="19" name="TextBox 18"/>
+          <p:cNvSpPr txBox="1"/>
+          <p:nvPr/>
+        </p:nvSpPr>
+        <p:spPr>
+          <a:xfrm>
+            <a:off x="1325880" y="2889504"/>
+            <a:ext cx="10058400" cy="256032"/>
           </a:xfrm>
           <a:prstGeom prst="rect">
             <a:avLst/>
@@ -7584,48 +7623,6 @@
               </a:spcAft>
             </a:pPr>
             <a:r>
-              <a:rPr sz="1300" b="0" i="0">
-                <a:solidFill>
-                  <a:srgbClr val="1C2830"/>
-                </a:solidFill>
-                <a:latin typeface="Malgun Gothic"/>
-                <a:ea typeface="Malgun Gothic"/>
-                <a:cs typeface="Malgun Gothic"/>
-              </a:rPr>
-              <a:t>회차를 고르고, 정원만 넘지 않게 받습니다.</a:t>
-            </a:r>
-          </a:p>
-        </p:txBody>
-      </p:sp>
-      <p:sp>
-        <p:nvSpPr>
-          <p:cNvPr id="19" name="TextBox 18"/>
-          <p:cNvSpPr txBox="1"/>
-          <p:nvPr/>
-        </p:nvSpPr>
-        <p:spPr>
-          <a:xfrm>
-            <a:off x="1325880" y="2889504"/>
-            <a:ext cx="7772400" cy="256032"/>
-          </a:xfrm>
-          <a:prstGeom prst="rect">
-            <a:avLst/>
-          </a:prstGeom>
-          <a:noFill/>
-        </p:spPr>
-        <p:txBody>
-          <a:bodyPr wrap="square" anchor="ctr"/>
-          <a:lstStyle/>
-          <a:p>
-            <a:pPr algn="l">
-              <a:spcBef>
-                <a:spcPts val="0"/>
-              </a:spcBef>
-              <a:spcAft>
-                <a:spcPts val="0"/>
-              </a:spcAft>
-            </a:pPr>
-            <a:r>
               <a:rPr sz="1300" b="1" i="0">
                 <a:solidFill>
                   <a:srgbClr val="5C6870"/>
@@ -7642,93 +7639,6 @@
       <p:sp>
         <p:nvSpPr>
           <p:cNvPr id="20" name="Rounded Rectangle 19"/>
-          <p:cNvSpPr/>
-          <p:nvPr/>
-        </p:nvSpPr>
-        <p:spPr>
-          <a:xfrm>
-            <a:off x="10195560" y="2523744"/>
-            <a:ext cx="1298448" cy="384048"/>
-          </a:xfrm>
-          <a:prstGeom prst="roundRect">
-            <a:avLst>
-              <a:gd name="adj" fmla="val 40000"/>
-            </a:avLst>
-          </a:prstGeom>
-          <a:solidFill>
-            <a:srgbClr val="1C6B64"/>
-          </a:solidFill>
-          <a:ln>
-            <a:noFill/>
-          </a:ln>
-        </p:spPr>
-        <p:style>
-          <a:lnRef idx="1">
-            <a:schemeClr val="accent1"/>
-          </a:lnRef>
-          <a:fillRef idx="3">
-            <a:schemeClr val="accent1"/>
-          </a:fillRef>
-          <a:effectRef idx="2">
-            <a:schemeClr val="accent1"/>
-          </a:effectRef>
-          <a:fontRef idx="minor">
-            <a:schemeClr val="lt1"/>
-          </a:fontRef>
-        </p:style>
-        <p:txBody>
-          <a:bodyPr rtlCol="0" anchor="ctr"/>
-          <a:lstStyle/>
-          <a:p>
-            <a:pPr algn="ctr"/>
-          </a:p>
-        </p:txBody>
-      </p:sp>
-      <p:sp>
-        <p:nvSpPr>
-          <p:cNvPr id="21" name="TextBox 20"/>
-          <p:cNvSpPr txBox="1"/>
-          <p:nvPr/>
-        </p:nvSpPr>
-        <p:spPr>
-          <a:xfrm>
-            <a:off x="10195560" y="2523744"/>
-            <a:ext cx="1298448" cy="384048"/>
-          </a:xfrm>
-          <a:prstGeom prst="rect">
-            <a:avLst/>
-          </a:prstGeom>
-          <a:noFill/>
-        </p:spPr>
-        <p:txBody>
-          <a:bodyPr wrap="square" anchor="ctr"/>
-          <a:lstStyle/>
-          <a:p>
-            <a:pPr algn="ctr">
-              <a:spcBef>
-                <a:spcPts val="0"/>
-              </a:spcBef>
-              <a:spcAft>
-                <a:spcPts val="0"/>
-              </a:spcAft>
-            </a:pPr>
-            <a:r>
-              <a:rPr sz="1300" b="1" i="0">
-                <a:solidFill>
-                  <a:srgbClr val="FFFFFF"/>
-                </a:solidFill>
-                <a:latin typeface="Malgun Gothic"/>
-                <a:ea typeface="Malgun Gothic"/>
-                <a:cs typeface="Malgun Gothic"/>
-              </a:rPr>
-              <a:t>JPA</a:t>
-            </a:r>
-          </a:p>
-        </p:txBody>
-      </p:sp>
-      <p:sp>
-        <p:nvSpPr>
-          <p:cNvPr id="22" name="Rounded Rectangle 21"/>
           <p:cNvSpPr/>
           <p:nvPr/>
         </p:nvSpPr>
@@ -7775,7 +7685,7 @@
       </p:sp>
       <p:sp>
         <p:nvSpPr>
-          <p:cNvPr id="23" name="Rectangle 22"/>
+          <p:cNvPr id="21" name="Rectangle 20"/>
           <p:cNvSpPr/>
           <p:nvPr/>
         </p:nvSpPr>
@@ -7818,7 +7728,7 @@
       </p:sp>
       <p:sp>
         <p:nvSpPr>
-          <p:cNvPr id="24" name="TextBox 23"/>
+          <p:cNvPr id="22" name="TextBox 21"/>
           <p:cNvSpPr txBox="1"/>
           <p:nvPr/>
         </p:nvSpPr>
@@ -7860,14 +7770,98 @@
       </p:sp>
       <p:sp>
         <p:nvSpPr>
+          <p:cNvPr id="23" name="TextBox 22"/>
+          <p:cNvSpPr txBox="1"/>
+          <p:nvPr/>
+        </p:nvSpPr>
+        <p:spPr>
+          <a:xfrm>
+            <a:off x="1325880" y="3364991"/>
+            <a:ext cx="7680960" cy="347472"/>
+          </a:xfrm>
+          <a:prstGeom prst="rect">
+            <a:avLst/>
+          </a:prstGeom>
+          <a:noFill/>
+        </p:spPr>
+        <p:txBody>
+          <a:bodyPr wrap="square" anchor="ctr"/>
+          <a:lstStyle/>
+          <a:p>
+            <a:pPr algn="l">
+              <a:spcBef>
+                <a:spcPts val="0"/>
+              </a:spcBef>
+              <a:spcAft>
+                <a:spcPts val="0"/>
+              </a:spcAft>
+            </a:pPr>
+            <a:r>
+              <a:rPr sz="2000" b="1" i="0">
+                <a:solidFill>
+                  <a:srgbClr val="1B2E3C"/>
+                </a:solidFill>
+                <a:latin typeface="Malgun Gothic"/>
+                <a:ea typeface="Malgun Gothic"/>
+                <a:cs typeface="Malgun Gothic"/>
+              </a:rPr>
+              <a:t>맛집 예약</a:t>
+            </a:r>
+          </a:p>
+        </p:txBody>
+      </p:sp>
+      <p:sp>
+        <p:nvSpPr>
+          <p:cNvPr id="24" name="TextBox 23"/>
+          <p:cNvSpPr txBox="1"/>
+          <p:nvPr/>
+        </p:nvSpPr>
+        <p:spPr>
+          <a:xfrm>
+            <a:off x="9418320" y="3364991"/>
+            <a:ext cx="2057400" cy="347472"/>
+          </a:xfrm>
+          <a:prstGeom prst="rect">
+            <a:avLst/>
+          </a:prstGeom>
+          <a:noFill/>
+        </p:spPr>
+        <p:txBody>
+          <a:bodyPr wrap="square" anchor="ctr"/>
+          <a:lstStyle/>
+          <a:p>
+            <a:pPr algn="r">
+              <a:spcBef>
+                <a:spcPts val="0"/>
+              </a:spcBef>
+              <a:spcAft>
+                <a:spcPts val="0"/>
+              </a:spcAft>
+            </a:pPr>
+            <a:r>
+              <a:rPr sz="1400" b="1" i="0">
+                <a:solidFill>
+                  <a:srgbClr val="1C6B64"/>
+                </a:solidFill>
+                <a:latin typeface="Malgun Gothic"/>
+                <a:ea typeface="Malgun Gothic"/>
+                <a:cs typeface="Malgun Gothic"/>
+              </a:rPr>
+              <a:t>쉬움</a:t>
+            </a:r>
+          </a:p>
+        </p:txBody>
+      </p:sp>
+      <p:sp>
+        <p:nvSpPr>
           <p:cNvPr id="25" name="TextBox 24"/>
           <p:cNvSpPr txBox="1"/>
           <p:nvPr/>
         </p:nvSpPr>
         <p:spPr>
           <a:xfrm>
-            <a:off x="1325880" y="3364991"/>
-            <a:ext cx="6035040" cy="347472"/>
+            <a:off x="1325880" y="3694176"/>
+            <a:ext cx="10058400" cy="256032"/>
           </a:xfrm>
           <a:prstGeom prst="rect">
             <a:avLst/>
@@ -7887,15 +7881,15 @@
               </a:spcAft>
             </a:pPr>
             <a:r>
-              <a:rPr sz="2000" b="1" i="0">
-                <a:solidFill>
-                  <a:srgbClr val="1B2E3C"/>
-                </a:solidFill>
-                <a:latin typeface="Malgun Gothic"/>
-                <a:ea typeface="Malgun Gothic"/>
-                <a:cs typeface="Malgun Gothic"/>
-              </a:rPr>
-              <a:t>맛집 예약</a:t>
+              <a:rPr sz="1300" b="0" i="0">
+                <a:solidFill>
+                  <a:srgbClr val="1C2830"/>
+                </a:solidFill>
+                <a:latin typeface="Malgun Gothic"/>
+                <a:ea typeface="Malgun Gothic"/>
+                <a:cs typeface="Malgun Gothic"/>
+              </a:rPr>
+              <a:t>식당, 시간, 인원만 받으면 됩니다.</a:t>
             </a:r>
           </a:p>
         </p:txBody>
@@ -7908,8 +7902,8 @@
         </p:nvSpPr>
         <p:spPr>
           <a:xfrm>
-            <a:off x="1325880" y="3694176"/>
-            <a:ext cx="7589520" cy="256032"/>
+            <a:off x="1325880" y="3931920"/>
+            <a:ext cx="10058400" cy="256032"/>
           </a:xfrm>
           <a:prstGeom prst="rect">
             <a:avLst/>
@@ -7929,48 +7923,6 @@
               </a:spcAft>
             </a:pPr>
             <a:r>
-              <a:rPr sz="1300" b="0" i="0">
-                <a:solidFill>
-                  <a:srgbClr val="1C2830"/>
-                </a:solidFill>
-                <a:latin typeface="Malgun Gothic"/>
-                <a:ea typeface="Malgun Gothic"/>
-                <a:cs typeface="Malgun Gothic"/>
-              </a:rPr>
-              <a:t>식당, 시간, 인원만 받으면 됩니다.</a:t>
-            </a:r>
-          </a:p>
-        </p:txBody>
-      </p:sp>
-      <p:sp>
-        <p:nvSpPr>
-          <p:cNvPr id="27" name="TextBox 26"/>
-          <p:cNvSpPr txBox="1"/>
-          <p:nvPr/>
-        </p:nvSpPr>
-        <p:spPr>
-          <a:xfrm>
-            <a:off x="1325880" y="3931920"/>
-            <a:ext cx="7772400" cy="256032"/>
-          </a:xfrm>
-          <a:prstGeom prst="rect">
-            <a:avLst/>
-          </a:prstGeom>
-          <a:noFill/>
-        </p:spPr>
-        <p:txBody>
-          <a:bodyPr wrap="square" anchor="ctr"/>
-          <a:lstStyle/>
-          <a:p>
-            <a:pPr algn="l">
-              <a:spcBef>
-                <a:spcPts val="0"/>
-              </a:spcBef>
-              <a:spcAft>
-                <a:spcPts val="0"/>
-              </a:spcAft>
-            </a:pPr>
-            <a:r>
               <a:rPr sz="1300" b="1" i="0">
                 <a:solidFill>
                   <a:srgbClr val="5C6870"/>
@@ -7986,94 +7938,7 @@
       </p:sp>
       <p:sp>
         <p:nvSpPr>
-          <p:cNvPr id="28" name="Rounded Rectangle 27"/>
-          <p:cNvSpPr/>
-          <p:nvPr/>
-        </p:nvSpPr>
-        <p:spPr>
-          <a:xfrm>
-            <a:off x="10195560" y="3566159"/>
-            <a:ext cx="1298448" cy="384048"/>
-          </a:xfrm>
-          <a:prstGeom prst="roundRect">
-            <a:avLst>
-              <a:gd name="adj" fmla="val 40000"/>
-            </a:avLst>
-          </a:prstGeom>
-          <a:solidFill>
-            <a:srgbClr val="1C6B64"/>
-          </a:solidFill>
-          <a:ln>
-            <a:noFill/>
-          </a:ln>
-        </p:spPr>
-        <p:style>
-          <a:lnRef idx="1">
-            <a:schemeClr val="accent1"/>
-          </a:lnRef>
-          <a:fillRef idx="3">
-            <a:schemeClr val="accent1"/>
-          </a:fillRef>
-          <a:effectRef idx="2">
-            <a:schemeClr val="accent1"/>
-          </a:effectRef>
-          <a:fontRef idx="minor">
-            <a:schemeClr val="lt1"/>
-          </a:fontRef>
-        </p:style>
-        <p:txBody>
-          <a:bodyPr rtlCol="0" anchor="ctr"/>
-          <a:lstStyle/>
-          <a:p>
-            <a:pPr algn="ctr"/>
-          </a:p>
-        </p:txBody>
-      </p:sp>
-      <p:sp>
-        <p:nvSpPr>
-          <p:cNvPr id="29" name="TextBox 28"/>
-          <p:cNvSpPr txBox="1"/>
-          <p:nvPr/>
-        </p:nvSpPr>
-        <p:spPr>
-          <a:xfrm>
-            <a:off x="10195560" y="3566159"/>
-            <a:ext cx="1298448" cy="384048"/>
-          </a:xfrm>
-          <a:prstGeom prst="rect">
-            <a:avLst/>
-          </a:prstGeom>
-          <a:noFill/>
-        </p:spPr>
-        <p:txBody>
-          <a:bodyPr wrap="square" anchor="ctr"/>
-          <a:lstStyle/>
-          <a:p>
-            <a:pPr algn="ctr">
-              <a:spcBef>
-                <a:spcPts val="0"/>
-              </a:spcBef>
-              <a:spcAft>
-                <a:spcPts val="0"/>
-              </a:spcAft>
-            </a:pPr>
-            <a:r>
-              <a:rPr sz="1300" b="1" i="0">
-                <a:solidFill>
-                  <a:srgbClr val="FFFFFF"/>
-                </a:solidFill>
-                <a:latin typeface="Malgun Gothic"/>
-                <a:ea typeface="Malgun Gothic"/>
-                <a:cs typeface="Malgun Gothic"/>
-              </a:rPr>
-              <a:t>MyBatis</a:t>
-            </a:r>
-          </a:p>
-        </p:txBody>
-      </p:sp>
-      <p:sp>
-        <p:nvSpPr>
-          <p:cNvPr id="30" name="Rounded Rectangle 29"/>
+          <p:cNvPr id="27" name="Rounded Rectangle 26"/>
           <p:cNvSpPr/>
           <p:nvPr/>
         </p:nvSpPr>
@@ -8120,7 +7985,7 @@
       </p:sp>
       <p:sp>
         <p:nvSpPr>
-          <p:cNvPr id="31" name="Rectangle 30"/>
+          <p:cNvPr id="28" name="Rectangle 27"/>
           <p:cNvSpPr/>
           <p:nvPr/>
         </p:nvSpPr>
@@ -8163,7 +8028,7 @@
       </p:sp>
       <p:sp>
         <p:nvSpPr>
-          <p:cNvPr id="32" name="TextBox 31"/>
+          <p:cNvPr id="29" name="TextBox 28"/>
           <p:cNvSpPr txBox="1"/>
           <p:nvPr/>
         </p:nvSpPr>
@@ -8205,14 +8070,140 @@
       </p:sp>
       <p:sp>
         <p:nvSpPr>
+          <p:cNvPr id="30" name="TextBox 29"/>
+          <p:cNvSpPr txBox="1"/>
+          <p:nvPr/>
+        </p:nvSpPr>
+        <p:spPr>
+          <a:xfrm>
+            <a:off x="1325880" y="4407407"/>
+            <a:ext cx="7680960" cy="347472"/>
+          </a:xfrm>
+          <a:prstGeom prst="rect">
+            <a:avLst/>
+          </a:prstGeom>
+          <a:noFill/>
+        </p:spPr>
+        <p:txBody>
+          <a:bodyPr wrap="square" anchor="ctr"/>
+          <a:lstStyle/>
+          <a:p>
+            <a:pPr algn="l">
+              <a:spcBef>
+                <a:spcPts val="0"/>
+              </a:spcBef>
+              <a:spcAft>
+                <a:spcPts val="0"/>
+              </a:spcAft>
+            </a:pPr>
+            <a:r>
+              <a:rPr sz="2000" b="1" i="0">
+                <a:solidFill>
+                  <a:srgbClr val="1B2E3C"/>
+                </a:solidFill>
+                <a:latin typeface="Malgun Gothic"/>
+                <a:ea typeface="Malgun Gothic"/>
+                <a:cs typeface="Malgun Gothic"/>
+              </a:rPr>
+              <a:t>펫 용품몰</a:t>
+            </a:r>
+          </a:p>
+        </p:txBody>
+      </p:sp>
+      <p:sp>
+        <p:nvSpPr>
+          <p:cNvPr id="31" name="TextBox 30"/>
+          <p:cNvSpPr txBox="1"/>
+          <p:nvPr/>
+        </p:nvSpPr>
+        <p:spPr>
+          <a:xfrm>
+            <a:off x="9418320" y="4407407"/>
+            <a:ext cx="2057400" cy="347472"/>
+          </a:xfrm>
+          <a:prstGeom prst="rect">
+            <a:avLst/>
+          </a:prstGeom>
+          <a:noFill/>
+        </p:spPr>
+        <p:txBody>
+          <a:bodyPr wrap="square" anchor="ctr"/>
+          <a:lstStyle/>
+          <a:p>
+            <a:pPr algn="r">
+              <a:spcBef>
+                <a:spcPts val="0"/>
+              </a:spcBef>
+              <a:spcAft>
+                <a:spcPts val="0"/>
+              </a:spcAft>
+            </a:pPr>
+            <a:r>
+              <a:rPr sz="1400" b="1" i="0">
+                <a:solidFill>
+                  <a:srgbClr val="E06A2C"/>
+                </a:solidFill>
+                <a:latin typeface="Malgun Gothic"/>
+                <a:ea typeface="Malgun Gothic"/>
+                <a:cs typeface="Malgun Gothic"/>
+              </a:rPr>
+              <a:t>보통</a:t>
+            </a:r>
+          </a:p>
+        </p:txBody>
+      </p:sp>
+      <p:sp>
+        <p:nvSpPr>
+          <p:cNvPr id="32" name="TextBox 31"/>
+          <p:cNvSpPr txBox="1"/>
+          <p:nvPr/>
+        </p:nvSpPr>
+        <p:spPr>
+          <a:xfrm>
+            <a:off x="1325880" y="4736592"/>
+            <a:ext cx="10058400" cy="256032"/>
+          </a:xfrm>
+          <a:prstGeom prst="rect">
+            <a:avLst/>
+          </a:prstGeom>
+          <a:noFill/>
+        </p:spPr>
+        <p:txBody>
+          <a:bodyPr wrap="square" anchor="ctr"/>
+          <a:lstStyle/>
+          <a:p>
+            <a:pPr algn="l">
+              <a:spcBef>
+                <a:spcPts val="0"/>
+              </a:spcBef>
+              <a:spcAft>
+                <a:spcPts val="0"/>
+              </a:spcAft>
+            </a:pPr>
+            <a:r>
+              <a:rPr sz="1300" b="0" i="0">
+                <a:solidFill>
+                  <a:srgbClr val="1C2830"/>
+                </a:solidFill>
+                <a:latin typeface="Malgun Gothic"/>
+                <a:ea typeface="Malgun Gothic"/>
+                <a:cs typeface="Malgun Gothic"/>
+              </a:rPr>
+              <a:t>담고 주문하면 재고가 줄어듭니다. 배송지가 있습니다.</a:t>
+            </a:r>
+          </a:p>
+        </p:txBody>
+      </p:sp>
+      <p:sp>
+        <p:nvSpPr>
           <p:cNvPr id="33" name="TextBox 32"/>
           <p:cNvSpPr txBox="1"/>
           <p:nvPr/>
         </p:nvSpPr>
         <p:spPr>
           <a:xfrm>
-            <a:off x="1325880" y="4407407"/>
-            <a:ext cx="6035040" cy="347472"/>
+            <a:off x="1325880" y="4974336"/>
+            <a:ext cx="10058400" cy="256032"/>
           </a:xfrm>
           <a:prstGeom prst="rect">
             <a:avLst/>
@@ -8232,90 +8223,6 @@
               </a:spcAft>
             </a:pPr>
             <a:r>
-              <a:rPr sz="2000" b="1" i="0">
-                <a:solidFill>
-                  <a:srgbClr val="1B2E3C"/>
-                </a:solidFill>
-                <a:latin typeface="Malgun Gothic"/>
-                <a:ea typeface="Malgun Gothic"/>
-                <a:cs typeface="Malgun Gothic"/>
-              </a:rPr>
-              <a:t>펫 용품몰</a:t>
-            </a:r>
-          </a:p>
-        </p:txBody>
-      </p:sp>
-      <p:sp>
-        <p:nvSpPr>
-          <p:cNvPr id="34" name="TextBox 33"/>
-          <p:cNvSpPr txBox="1"/>
-          <p:nvPr/>
-        </p:nvSpPr>
-        <p:spPr>
-          <a:xfrm>
-            <a:off x="1325880" y="4736592"/>
-            <a:ext cx="7589520" cy="256032"/>
-          </a:xfrm>
-          <a:prstGeom prst="rect">
-            <a:avLst/>
-          </a:prstGeom>
-          <a:noFill/>
-        </p:spPr>
-        <p:txBody>
-          <a:bodyPr wrap="square" anchor="ctr"/>
-          <a:lstStyle/>
-          <a:p>
-            <a:pPr algn="l">
-              <a:spcBef>
-                <a:spcPts val="0"/>
-              </a:spcBef>
-              <a:spcAft>
-                <a:spcPts val="0"/>
-              </a:spcAft>
-            </a:pPr>
-            <a:r>
-              <a:rPr sz="1300" b="0" i="0">
-                <a:solidFill>
-                  <a:srgbClr val="1C2830"/>
-                </a:solidFill>
-                <a:latin typeface="Malgun Gothic"/>
-                <a:ea typeface="Malgun Gothic"/>
-                <a:cs typeface="Malgun Gothic"/>
-              </a:rPr>
-              <a:t>담고 주문하면 재고가 줄어듭니다. 배송지가 있습니다.</a:t>
-            </a:r>
-          </a:p>
-        </p:txBody>
-      </p:sp>
-      <p:sp>
-        <p:nvSpPr>
-          <p:cNvPr id="35" name="TextBox 34"/>
-          <p:cNvSpPr txBox="1"/>
-          <p:nvPr/>
-        </p:nvSpPr>
-        <p:spPr>
-          <a:xfrm>
-            <a:off x="1325880" y="4974336"/>
-            <a:ext cx="7772400" cy="256032"/>
-          </a:xfrm>
-          <a:prstGeom prst="rect">
-            <a:avLst/>
-          </a:prstGeom>
-          <a:noFill/>
-        </p:spPr>
-        <p:txBody>
-          <a:bodyPr wrap="square" anchor="ctr"/>
-          <a:lstStyle/>
-          <a:p>
-            <a:pPr algn="l">
-              <a:spcBef>
-                <a:spcPts val="0"/>
-              </a:spcBef>
-              <a:spcAft>
-                <a:spcPts val="0"/>
-              </a:spcAft>
-            </a:pPr>
-            <a:r>
               <a:rPr sz="1300" b="1" i="0">
                 <a:solidFill>
                   <a:srgbClr val="5C6870"/>
@@ -8331,94 +8238,7 @@
       </p:sp>
       <p:sp>
         <p:nvSpPr>
-          <p:cNvPr id="36" name="Rounded Rectangle 35"/>
-          <p:cNvSpPr/>
-          <p:nvPr/>
-        </p:nvSpPr>
-        <p:spPr>
-          <a:xfrm>
-            <a:off x="10195560" y="4608575"/>
-            <a:ext cx="1298448" cy="384048"/>
-          </a:xfrm>
-          <a:prstGeom prst="roundRect">
-            <a:avLst>
-              <a:gd name="adj" fmla="val 40000"/>
-            </a:avLst>
-          </a:prstGeom>
-          <a:solidFill>
-            <a:srgbClr val="E06A2C"/>
-          </a:solidFill>
-          <a:ln>
-            <a:noFill/>
-          </a:ln>
-        </p:spPr>
-        <p:style>
-          <a:lnRef idx="1">
-            <a:schemeClr val="accent1"/>
-          </a:lnRef>
-          <a:fillRef idx="3">
-            <a:schemeClr val="accent1"/>
-          </a:fillRef>
-          <a:effectRef idx="2">
-            <a:schemeClr val="accent1"/>
-          </a:effectRef>
-          <a:fontRef idx="minor">
-            <a:schemeClr val="lt1"/>
-          </a:fontRef>
-        </p:style>
-        <p:txBody>
-          <a:bodyPr rtlCol="0" anchor="ctr"/>
-          <a:lstStyle/>
-          <a:p>
-            <a:pPr algn="ctr"/>
-          </a:p>
-        </p:txBody>
-      </p:sp>
-      <p:sp>
-        <p:nvSpPr>
-          <p:cNvPr id="37" name="TextBox 36"/>
-          <p:cNvSpPr txBox="1"/>
-          <p:nvPr/>
-        </p:nvSpPr>
-        <p:spPr>
-          <a:xfrm>
-            <a:off x="10195560" y="4608575"/>
-            <a:ext cx="1298448" cy="384048"/>
-          </a:xfrm>
-          <a:prstGeom prst="rect">
-            <a:avLst/>
-          </a:prstGeom>
-          <a:noFill/>
-        </p:spPr>
-        <p:txBody>
-          <a:bodyPr wrap="square" anchor="ctr"/>
-          <a:lstStyle/>
-          <a:p>
-            <a:pPr algn="ctr">
-              <a:spcBef>
-                <a:spcPts val="0"/>
-              </a:spcBef>
-              <a:spcAft>
-                <a:spcPts val="0"/>
-              </a:spcAft>
-            </a:pPr>
-            <a:r>
-              <a:rPr sz="1300" b="1" i="0">
-                <a:solidFill>
-                  <a:srgbClr val="FFFFFF"/>
-                </a:solidFill>
-                <a:latin typeface="Malgun Gothic"/>
-                <a:ea typeface="Malgun Gothic"/>
-                <a:cs typeface="Malgun Gothic"/>
-              </a:rPr>
-              <a:t>MyBatis</a:t>
-            </a:r>
-          </a:p>
-        </p:txBody>
-      </p:sp>
-      <p:sp>
-        <p:nvSpPr>
-          <p:cNvPr id="38" name="Rounded Rectangle 37"/>
+          <p:cNvPr id="34" name="Rounded Rectangle 33"/>
           <p:cNvSpPr/>
           <p:nvPr/>
         </p:nvSpPr>
@@ -8465,7 +8285,7 @@
       </p:sp>
       <p:sp>
         <p:nvSpPr>
-          <p:cNvPr id="39" name="Rectangle 38"/>
+          <p:cNvPr id="35" name="Rectangle 34"/>
           <p:cNvSpPr/>
           <p:nvPr/>
         </p:nvSpPr>
@@ -8508,7 +8328,7 @@
       </p:sp>
       <p:sp>
         <p:nvSpPr>
-          <p:cNvPr id="40" name="TextBox 39"/>
+          <p:cNvPr id="36" name="TextBox 35"/>
           <p:cNvSpPr txBox="1"/>
           <p:nvPr/>
         </p:nvSpPr>
@@ -8550,220 +8370,175 @@
       </p:sp>
       <p:sp>
         <p:nvSpPr>
+          <p:cNvPr id="37" name="TextBox 36"/>
+          <p:cNvSpPr txBox="1"/>
+          <p:nvPr/>
+        </p:nvSpPr>
+        <p:spPr>
+          <a:xfrm>
+            <a:off x="1325880" y="5449823"/>
+            <a:ext cx="7680960" cy="347472"/>
+          </a:xfrm>
+          <a:prstGeom prst="rect">
+            <a:avLst/>
+          </a:prstGeom>
+          <a:noFill/>
+        </p:spPr>
+        <p:txBody>
+          <a:bodyPr wrap="square" anchor="ctr"/>
+          <a:lstStyle/>
+          <a:p>
+            <a:pPr algn="l">
+              <a:spcBef>
+                <a:spcPts val="0"/>
+              </a:spcBef>
+              <a:spcAft>
+                <a:spcPts val="0"/>
+              </a:spcAft>
+            </a:pPr>
+            <a:r>
+              <a:rPr sz="2000" b="1" i="0">
+                <a:solidFill>
+                  <a:srgbClr val="1B2E3C"/>
+                </a:solidFill>
+                <a:latin typeface="Malgun Gothic"/>
+                <a:ea typeface="Malgun Gothic"/>
+                <a:cs typeface="Malgun Gothic"/>
+              </a:rPr>
+              <a:t>온라인 서점</a:t>
+            </a:r>
+          </a:p>
+        </p:txBody>
+      </p:sp>
+      <p:sp>
+        <p:nvSpPr>
+          <p:cNvPr id="38" name="TextBox 37"/>
+          <p:cNvSpPr txBox="1"/>
+          <p:nvPr/>
+        </p:nvSpPr>
+        <p:spPr>
+          <a:xfrm>
+            <a:off x="9418320" y="5449823"/>
+            <a:ext cx="2057400" cy="347472"/>
+          </a:xfrm>
+          <a:prstGeom prst="rect">
+            <a:avLst/>
+          </a:prstGeom>
+          <a:noFill/>
+        </p:spPr>
+        <p:txBody>
+          <a:bodyPr wrap="square" anchor="ctr"/>
+          <a:lstStyle/>
+          <a:p>
+            <a:pPr algn="r">
+              <a:spcBef>
+                <a:spcPts val="0"/>
+              </a:spcBef>
+              <a:spcAft>
+                <a:spcPts val="0"/>
+              </a:spcAft>
+            </a:pPr>
+            <a:r>
+              <a:rPr sz="1400" b="1" i="0">
+                <a:solidFill>
+                  <a:srgbClr val="E06A2C"/>
+                </a:solidFill>
+                <a:latin typeface="Malgun Gothic"/>
+                <a:ea typeface="Malgun Gothic"/>
+                <a:cs typeface="Malgun Gothic"/>
+              </a:rPr>
+              <a:t>보통</a:t>
+            </a:r>
+          </a:p>
+        </p:txBody>
+      </p:sp>
+      <p:sp>
+        <p:nvSpPr>
+          <p:cNvPr id="39" name="TextBox 38"/>
+          <p:cNvSpPr txBox="1"/>
+          <p:nvPr/>
+        </p:nvSpPr>
+        <p:spPr>
+          <a:xfrm>
+            <a:off x="1325880" y="5779007"/>
+            <a:ext cx="10058400" cy="256032"/>
+          </a:xfrm>
+          <a:prstGeom prst="rect">
+            <a:avLst/>
+          </a:prstGeom>
+          <a:noFill/>
+        </p:spPr>
+        <p:txBody>
+          <a:bodyPr wrap="square" anchor="ctr"/>
+          <a:lstStyle/>
+          <a:p>
+            <a:pPr algn="l">
+              <a:spcBef>
+                <a:spcPts val="0"/>
+              </a:spcBef>
+              <a:spcAft>
+                <a:spcPts val="0"/>
+              </a:spcAft>
+            </a:pPr>
+            <a:r>
+              <a:rPr sz="1300" b="0" i="0">
+                <a:solidFill>
+                  <a:srgbClr val="1C2830"/>
+                </a:solidFill>
+                <a:latin typeface="Malgun Gothic"/>
+                <a:ea typeface="Malgun Gothic"/>
+                <a:cs typeface="Malgun Gothic"/>
+              </a:rPr>
+              <a:t>펫 용품몰과 같고, 리뷰만 더합니다.</a:t>
+            </a:r>
+          </a:p>
+        </p:txBody>
+      </p:sp>
+      <p:sp>
+        <p:nvSpPr>
+          <p:cNvPr id="40" name="TextBox 39"/>
+          <p:cNvSpPr txBox="1"/>
+          <p:nvPr/>
+        </p:nvSpPr>
+        <p:spPr>
+          <a:xfrm>
+            <a:off x="1325880" y="6016751"/>
+            <a:ext cx="10058400" cy="256032"/>
+          </a:xfrm>
+          <a:prstGeom prst="rect">
+            <a:avLst/>
+          </a:prstGeom>
+          <a:noFill/>
+        </p:spPr>
+        <p:txBody>
+          <a:bodyPr wrap="square" anchor="ctr"/>
+          <a:lstStyle/>
+          <a:p>
+            <a:pPr algn="l">
+              <a:spcBef>
+                <a:spcPts val="0"/>
+              </a:spcBef>
+              <a:spcAft>
+                <a:spcPts val="0"/>
+              </a:spcAft>
+            </a:pPr>
+            <a:r>
+              <a:rPr sz="1300" b="1" i="0">
+                <a:solidFill>
+                  <a:srgbClr val="5C6870"/>
+                </a:solidFill>
+                <a:latin typeface="Malgun Gothic"/>
+                <a:ea typeface="Malgun Gothic"/>
+                <a:cs typeface="Malgun Gothic"/>
+              </a:rPr>
+              <a:t>A 회원·배송지   B 도서   C 주문   D 관리자</a:t>
+            </a:r>
+          </a:p>
+        </p:txBody>
+      </p:sp>
+      <p:sp>
+        <p:nvSpPr>
           <p:cNvPr id="41" name="TextBox 40"/>
-          <p:cNvSpPr txBox="1"/>
-          <p:nvPr/>
-        </p:nvSpPr>
-        <p:spPr>
-          <a:xfrm>
-            <a:off x="1325880" y="5449823"/>
-            <a:ext cx="6035040" cy="347472"/>
-          </a:xfrm>
-          <a:prstGeom prst="rect">
-            <a:avLst/>
-          </a:prstGeom>
-          <a:noFill/>
-        </p:spPr>
-        <p:txBody>
-          <a:bodyPr wrap="square" anchor="ctr"/>
-          <a:lstStyle/>
-          <a:p>
-            <a:pPr algn="l">
-              <a:spcBef>
-                <a:spcPts val="0"/>
-              </a:spcBef>
-              <a:spcAft>
-                <a:spcPts val="0"/>
-              </a:spcAft>
-            </a:pPr>
-            <a:r>
-              <a:rPr sz="2000" b="1" i="0">
-                <a:solidFill>
-                  <a:srgbClr val="1B2E3C"/>
-                </a:solidFill>
-                <a:latin typeface="Malgun Gothic"/>
-                <a:ea typeface="Malgun Gothic"/>
-                <a:cs typeface="Malgun Gothic"/>
-              </a:rPr>
-              <a:t>온라인 서점</a:t>
-            </a:r>
-          </a:p>
-        </p:txBody>
-      </p:sp>
-      <p:sp>
-        <p:nvSpPr>
-          <p:cNvPr id="42" name="TextBox 41"/>
-          <p:cNvSpPr txBox="1"/>
-          <p:nvPr/>
-        </p:nvSpPr>
-        <p:spPr>
-          <a:xfrm>
-            <a:off x="1325880" y="5779007"/>
-            <a:ext cx="7589520" cy="256032"/>
-          </a:xfrm>
-          <a:prstGeom prst="rect">
-            <a:avLst/>
-          </a:prstGeom>
-          <a:noFill/>
-        </p:spPr>
-        <p:txBody>
-          <a:bodyPr wrap="square" anchor="ctr"/>
-          <a:lstStyle/>
-          <a:p>
-            <a:pPr algn="l">
-              <a:spcBef>
-                <a:spcPts val="0"/>
-              </a:spcBef>
-              <a:spcAft>
-                <a:spcPts val="0"/>
-              </a:spcAft>
-            </a:pPr>
-            <a:r>
-              <a:rPr sz="1300" b="0" i="0">
-                <a:solidFill>
-                  <a:srgbClr val="1C2830"/>
-                </a:solidFill>
-                <a:latin typeface="Malgun Gothic"/>
-                <a:ea typeface="Malgun Gothic"/>
-                <a:cs typeface="Malgun Gothic"/>
-              </a:rPr>
-              <a:t>펫 용품몰과 같고, 리뷰만 더합니다.</a:t>
-            </a:r>
-          </a:p>
-        </p:txBody>
-      </p:sp>
-      <p:sp>
-        <p:nvSpPr>
-          <p:cNvPr id="43" name="TextBox 42"/>
-          <p:cNvSpPr txBox="1"/>
-          <p:nvPr/>
-        </p:nvSpPr>
-        <p:spPr>
-          <a:xfrm>
-            <a:off x="1325880" y="6016751"/>
-            <a:ext cx="7772400" cy="256032"/>
-          </a:xfrm>
-          <a:prstGeom prst="rect">
-            <a:avLst/>
-          </a:prstGeom>
-          <a:noFill/>
-        </p:spPr>
-        <p:txBody>
-          <a:bodyPr wrap="square" anchor="ctr"/>
-          <a:lstStyle/>
-          <a:p>
-            <a:pPr algn="l">
-              <a:spcBef>
-                <a:spcPts val="0"/>
-              </a:spcBef>
-              <a:spcAft>
-                <a:spcPts val="0"/>
-              </a:spcAft>
-            </a:pPr>
-            <a:r>
-              <a:rPr sz="1300" b="1" i="0">
-                <a:solidFill>
-                  <a:srgbClr val="5C6870"/>
-                </a:solidFill>
-                <a:latin typeface="Malgun Gothic"/>
-                <a:ea typeface="Malgun Gothic"/>
-                <a:cs typeface="Malgun Gothic"/>
-              </a:rPr>
-              <a:t>A 회원·배송지   B 도서   C 주문   D 관리자</a:t>
-            </a:r>
-          </a:p>
-        </p:txBody>
-      </p:sp>
-      <p:sp>
-        <p:nvSpPr>
-          <p:cNvPr id="44" name="Rounded Rectangle 43"/>
-          <p:cNvSpPr/>
-          <p:nvPr/>
-        </p:nvSpPr>
-        <p:spPr>
-          <a:xfrm>
-            <a:off x="10195560" y="5650991"/>
-            <a:ext cx="1298448" cy="384048"/>
-          </a:xfrm>
-          <a:prstGeom prst="roundRect">
-            <a:avLst>
-              <a:gd name="adj" fmla="val 40000"/>
-            </a:avLst>
-          </a:prstGeom>
-          <a:solidFill>
-            <a:srgbClr val="E06A2C"/>
-          </a:solidFill>
-          <a:ln>
-            <a:noFill/>
-          </a:ln>
-        </p:spPr>
-        <p:style>
-          <a:lnRef idx="1">
-            <a:schemeClr val="accent1"/>
-          </a:lnRef>
-          <a:fillRef idx="3">
-            <a:schemeClr val="accent1"/>
-          </a:fillRef>
-          <a:effectRef idx="2">
-            <a:schemeClr val="accent1"/>
-          </a:effectRef>
-          <a:fontRef idx="minor">
-            <a:schemeClr val="lt1"/>
-          </a:fontRef>
-        </p:style>
-        <p:txBody>
-          <a:bodyPr rtlCol="0" anchor="ctr"/>
-          <a:lstStyle/>
-          <a:p>
-            <a:pPr algn="ctr"/>
-          </a:p>
-        </p:txBody>
-      </p:sp>
-      <p:sp>
-        <p:nvSpPr>
-          <p:cNvPr id="45" name="TextBox 44"/>
-          <p:cNvSpPr txBox="1"/>
-          <p:nvPr/>
-        </p:nvSpPr>
-        <p:spPr>
-          <a:xfrm>
-            <a:off x="10195560" y="5650991"/>
-            <a:ext cx="1298448" cy="384048"/>
-          </a:xfrm>
-          <a:prstGeom prst="rect">
-            <a:avLst/>
-          </a:prstGeom>
-          <a:noFill/>
-        </p:spPr>
-        <p:txBody>
-          <a:bodyPr wrap="square" anchor="ctr"/>
-          <a:lstStyle/>
-          <a:p>
-            <a:pPr algn="ctr">
-              <a:spcBef>
-                <a:spcPts val="0"/>
-              </a:spcBef>
-              <a:spcAft>
-                <a:spcPts val="0"/>
-              </a:spcAft>
-            </a:pPr>
-            <a:r>
-              <a:rPr sz="1300" b="1" i="0">
-                <a:solidFill>
-                  <a:srgbClr val="FFFFFF"/>
-                </a:solidFill>
-                <a:latin typeface="Malgun Gothic"/>
-                <a:ea typeface="Malgun Gothic"/>
-                <a:cs typeface="Malgun Gothic"/>
-              </a:rPr>
-              <a:t>JPA</a:t>
-            </a:r>
-          </a:p>
-        </p:txBody>
-      </p:sp>
-      <p:sp>
-        <p:nvSpPr>
-          <p:cNvPr id="46" name="TextBox 45"/>
           <p:cNvSpPr txBox="1"/>
           <p:nvPr/>
         </p:nvSpPr>
@@ -8805,7 +8580,7 @@
       </p:sp>
       <p:sp>
         <p:nvSpPr>
-          <p:cNvPr id="47" name="TextBox 46"/>
+          <p:cNvPr id="42" name="TextBox 41"/>
           <p:cNvSpPr txBox="1"/>
           <p:nvPr/>
         </p:nvSpPr>
@@ -9176,7 +8951,7 @@
         <p:spPr>
           <a:xfrm>
             <a:off x="1325880" y="1280160"/>
-            <a:ext cx="6035040" cy="347472"/>
+            <a:ext cx="7680960" cy="347472"/>
           </a:xfrm>
           <a:prstGeom prst="rect">
             <a:avLst/>
@@ -9217,8 +8992,50 @@
         </p:nvSpPr>
         <p:spPr>
           <a:xfrm>
+            <a:off x="9418320" y="1280160"/>
+            <a:ext cx="2057400" cy="347472"/>
+          </a:xfrm>
+          <a:prstGeom prst="rect">
+            <a:avLst/>
+          </a:prstGeom>
+          <a:noFill/>
+        </p:spPr>
+        <p:txBody>
+          <a:bodyPr wrap="square" anchor="ctr"/>
+          <a:lstStyle/>
+          <a:p>
+            <a:pPr algn="r">
+              <a:spcBef>
+                <a:spcPts val="0"/>
+              </a:spcBef>
+              <a:spcAft>
+                <a:spcPts val="0"/>
+              </a:spcAft>
+            </a:pPr>
+            <a:r>
+              <a:rPr sz="1400" b="1" i="0">
+                <a:solidFill>
+                  <a:srgbClr val="E06A2C"/>
+                </a:solidFill>
+                <a:latin typeface="Malgun Gothic"/>
+                <a:ea typeface="Malgun Gothic"/>
+                <a:cs typeface="Malgun Gothic"/>
+              </a:rPr>
+              <a:t>보통</a:t>
+            </a:r>
+          </a:p>
+        </p:txBody>
+      </p:sp>
+      <p:sp>
+        <p:nvSpPr>
+          <p:cNvPr id="11" name="TextBox 10"/>
+          <p:cNvSpPr txBox="1"/>
+          <p:nvPr/>
+        </p:nvSpPr>
+        <p:spPr>
+          <a:xfrm>
             <a:off x="1325880" y="1609344"/>
-            <a:ext cx="7589520" cy="256032"/>
+            <a:ext cx="10058400" cy="256032"/>
           </a:xfrm>
           <a:prstGeom prst="rect">
             <a:avLst/>
@@ -9253,14 +9070,14 @@
       </p:sp>
       <p:sp>
         <p:nvSpPr>
-          <p:cNvPr id="11" name="TextBox 10"/>
+          <p:cNvPr id="12" name="TextBox 11"/>
           <p:cNvSpPr txBox="1"/>
           <p:nvPr/>
         </p:nvSpPr>
         <p:spPr>
           <a:xfrm>
             <a:off x="1325880" y="1847088"/>
-            <a:ext cx="7772400" cy="256032"/>
+            <a:ext cx="10058400" cy="256032"/>
           </a:xfrm>
           <a:prstGeom prst="rect">
             <a:avLst/>
@@ -9295,94 +9112,7 @@
       </p:sp>
       <p:sp>
         <p:nvSpPr>
-          <p:cNvPr id="12" name="Rounded Rectangle 11"/>
-          <p:cNvSpPr/>
-          <p:nvPr/>
-        </p:nvSpPr>
-        <p:spPr>
-          <a:xfrm>
-            <a:off x="10195560" y="1481328"/>
-            <a:ext cx="1298448" cy="384048"/>
-          </a:xfrm>
-          <a:prstGeom prst="roundRect">
-            <a:avLst>
-              <a:gd name="adj" fmla="val 40000"/>
-            </a:avLst>
-          </a:prstGeom>
-          <a:solidFill>
-            <a:srgbClr val="E06A2C"/>
-          </a:solidFill>
-          <a:ln>
-            <a:noFill/>
-          </a:ln>
-        </p:spPr>
-        <p:style>
-          <a:lnRef idx="1">
-            <a:schemeClr val="accent1"/>
-          </a:lnRef>
-          <a:fillRef idx="3">
-            <a:schemeClr val="accent1"/>
-          </a:fillRef>
-          <a:effectRef idx="2">
-            <a:schemeClr val="accent1"/>
-          </a:effectRef>
-          <a:fontRef idx="minor">
-            <a:schemeClr val="lt1"/>
-          </a:fontRef>
-        </p:style>
-        <p:txBody>
-          <a:bodyPr rtlCol="0" anchor="ctr"/>
-          <a:lstStyle/>
-          <a:p>
-            <a:pPr algn="ctr"/>
-          </a:p>
-        </p:txBody>
-      </p:sp>
-      <p:sp>
-        <p:nvSpPr>
-          <p:cNvPr id="13" name="TextBox 12"/>
-          <p:cNvSpPr txBox="1"/>
-          <p:nvPr/>
-        </p:nvSpPr>
-        <p:spPr>
-          <a:xfrm>
-            <a:off x="10195560" y="1481328"/>
-            <a:ext cx="1298448" cy="384048"/>
-          </a:xfrm>
-          <a:prstGeom prst="rect">
-            <a:avLst/>
-          </a:prstGeom>
-          <a:noFill/>
-        </p:spPr>
-        <p:txBody>
-          <a:bodyPr wrap="square" anchor="ctr"/>
-          <a:lstStyle/>
-          <a:p>
-            <a:pPr algn="ctr">
-              <a:spcBef>
-                <a:spcPts val="0"/>
-              </a:spcBef>
-              <a:spcAft>
-                <a:spcPts val="0"/>
-              </a:spcAft>
-            </a:pPr>
-            <a:r>
-              <a:rPr sz="1300" b="1" i="0">
-                <a:solidFill>
-                  <a:srgbClr val="FFFFFF"/>
-                </a:solidFill>
-                <a:latin typeface="Malgun Gothic"/>
-                <a:ea typeface="Malgun Gothic"/>
-                <a:cs typeface="Malgun Gothic"/>
-              </a:rPr>
-              <a:t>JPA</a:t>
-            </a:r>
-          </a:p>
-        </p:txBody>
-      </p:sp>
-      <p:sp>
-        <p:nvSpPr>
-          <p:cNvPr id="14" name="Rounded Rectangle 13"/>
+          <p:cNvPr id="13" name="Rounded Rectangle 12"/>
           <p:cNvSpPr/>
           <p:nvPr/>
         </p:nvSpPr>
@@ -9429,7 +9159,7 @@
       </p:sp>
       <p:sp>
         <p:nvSpPr>
-          <p:cNvPr id="15" name="Rectangle 14"/>
+          <p:cNvPr id="14" name="Rectangle 13"/>
           <p:cNvSpPr/>
           <p:nvPr/>
         </p:nvSpPr>
@@ -9472,7 +9202,7 @@
       </p:sp>
       <p:sp>
         <p:nvSpPr>
-          <p:cNvPr id="16" name="TextBox 15"/>
+          <p:cNvPr id="15" name="TextBox 14"/>
           <p:cNvSpPr txBox="1"/>
           <p:nvPr/>
         </p:nvSpPr>
@@ -9514,14 +9244,56 @@
       </p:sp>
       <p:sp>
         <p:nvSpPr>
+          <p:cNvPr id="16" name="TextBox 15"/>
+          <p:cNvSpPr txBox="1"/>
+          <p:nvPr/>
+        </p:nvSpPr>
+        <p:spPr>
+          <a:xfrm>
+            <a:off x="1325880" y="2322576"/>
+            <a:ext cx="7680960" cy="347472"/>
+          </a:xfrm>
+          <a:prstGeom prst="rect">
+            <a:avLst/>
+          </a:prstGeom>
+          <a:noFill/>
+        </p:spPr>
+        <p:txBody>
+          <a:bodyPr wrap="square" anchor="ctr"/>
+          <a:lstStyle/>
+          <a:p>
+            <a:pPr algn="l">
+              <a:spcBef>
+                <a:spcPts val="0"/>
+              </a:spcBef>
+              <a:spcAft>
+                <a:spcPts val="0"/>
+              </a:spcAft>
+            </a:pPr>
+            <a:r>
+              <a:rPr sz="2000" b="1" i="0">
+                <a:solidFill>
+                  <a:srgbClr val="1B2E3C"/>
+                </a:solidFill>
+                <a:latin typeface="Malgun Gothic"/>
+                <a:ea typeface="Malgun Gothic"/>
+                <a:cs typeface="Malgun Gothic"/>
+              </a:rPr>
+              <a:t>세탁 수거</a:t>
+            </a:r>
+          </a:p>
+        </p:txBody>
+      </p:sp>
+      <p:sp>
+        <p:nvSpPr>
           <p:cNvPr id="17" name="TextBox 16"/>
           <p:cNvSpPr txBox="1"/>
           <p:nvPr/>
         </p:nvSpPr>
         <p:spPr>
           <a:xfrm>
-            <a:off x="1325880" y="2322576"/>
-            <a:ext cx="6035040" cy="347472"/>
+            <a:off x="9418320" y="2322576"/>
+            <a:ext cx="2057400" cy="347472"/>
           </a:xfrm>
           <a:prstGeom prst="rect">
             <a:avLst/>
@@ -9532,6 +9304,48 @@
           <a:bodyPr wrap="square" anchor="ctr"/>
           <a:lstStyle/>
           <a:p>
+            <a:pPr algn="r">
+              <a:spcBef>
+                <a:spcPts val="0"/>
+              </a:spcBef>
+              <a:spcAft>
+                <a:spcPts val="0"/>
+              </a:spcAft>
+            </a:pPr>
+            <a:r>
+              <a:rPr sz="1400" b="1" i="0">
+                <a:solidFill>
+                  <a:srgbClr val="E06A2C"/>
+                </a:solidFill>
+                <a:latin typeface="Malgun Gothic"/>
+                <a:ea typeface="Malgun Gothic"/>
+                <a:cs typeface="Malgun Gothic"/>
+              </a:rPr>
+              <a:t>보통</a:t>
+            </a:r>
+          </a:p>
+        </p:txBody>
+      </p:sp>
+      <p:sp>
+        <p:nvSpPr>
+          <p:cNvPr id="18" name="TextBox 17"/>
+          <p:cNvSpPr txBox="1"/>
+          <p:nvPr/>
+        </p:nvSpPr>
+        <p:spPr>
+          <a:xfrm>
+            <a:off x="1325880" y="2651760"/>
+            <a:ext cx="10058400" cy="256032"/>
+          </a:xfrm>
+          <a:prstGeom prst="rect">
+            <a:avLst/>
+          </a:prstGeom>
+          <a:noFill/>
+        </p:spPr>
+        <p:txBody>
+          <a:bodyPr wrap="square" anchor="ctr"/>
+          <a:lstStyle/>
+          <a:p>
             <a:pPr algn="l">
               <a:spcBef>
                 <a:spcPts val="0"/>
@@ -9541,29 +9355,29 @@
               </a:spcAft>
             </a:pPr>
             <a:r>
-              <a:rPr sz="2000" b="1" i="0">
-                <a:solidFill>
-                  <a:srgbClr val="1B2E3C"/>
-                </a:solidFill>
-                <a:latin typeface="Malgun Gothic"/>
-                <a:ea typeface="Malgun Gothic"/>
-                <a:cs typeface="Malgun Gothic"/>
-              </a:rPr>
-              <a:t>세탁 수거</a:t>
-            </a:r>
-          </a:p>
-        </p:txBody>
-      </p:sp>
-      <p:sp>
-        <p:nvSpPr>
-          <p:cNvPr id="18" name="TextBox 17"/>
-          <p:cNvSpPr txBox="1"/>
-          <p:nvPr/>
-        </p:nvSpPr>
-        <p:spPr>
-          <a:xfrm>
-            <a:off x="1325880" y="2651760"/>
-            <a:ext cx="7589520" cy="256032"/>
+              <a:rPr sz="1300" b="0" i="0">
+                <a:solidFill>
+                  <a:srgbClr val="1C2830"/>
+                </a:solidFill>
+                <a:latin typeface="Malgun Gothic"/>
+                <a:ea typeface="Malgun Gothic"/>
+                <a:cs typeface="Malgun Gothic"/>
+              </a:rPr>
+              <a:t>수거 주소를 받고, 상태를 다음 단계로 옮깁니다.</a:t>
+            </a:r>
+          </a:p>
+        </p:txBody>
+      </p:sp>
+      <p:sp>
+        <p:nvSpPr>
+          <p:cNvPr id="19" name="TextBox 18"/>
+          <p:cNvSpPr txBox="1"/>
+          <p:nvPr/>
+        </p:nvSpPr>
+        <p:spPr>
+          <a:xfrm>
+            <a:off x="1325880" y="2889504"/>
+            <a:ext cx="10058400" cy="256032"/>
           </a:xfrm>
           <a:prstGeom prst="rect">
             <a:avLst/>
@@ -9583,48 +9397,6 @@
               </a:spcAft>
             </a:pPr>
             <a:r>
-              <a:rPr sz="1300" b="0" i="0">
-                <a:solidFill>
-                  <a:srgbClr val="1C2830"/>
-                </a:solidFill>
-                <a:latin typeface="Malgun Gothic"/>
-                <a:ea typeface="Malgun Gothic"/>
-                <a:cs typeface="Malgun Gothic"/>
-              </a:rPr>
-              <a:t>수거 주소를 받고, 상태를 다음 단계로 옮깁니다.</a:t>
-            </a:r>
-          </a:p>
-        </p:txBody>
-      </p:sp>
-      <p:sp>
-        <p:nvSpPr>
-          <p:cNvPr id="19" name="TextBox 18"/>
-          <p:cNvSpPr txBox="1"/>
-          <p:nvPr/>
-        </p:nvSpPr>
-        <p:spPr>
-          <a:xfrm>
-            <a:off x="1325880" y="2889504"/>
-            <a:ext cx="7772400" cy="256032"/>
-          </a:xfrm>
-          <a:prstGeom prst="rect">
-            <a:avLst/>
-          </a:prstGeom>
-          <a:noFill/>
-        </p:spPr>
-        <p:txBody>
-          <a:bodyPr wrap="square" anchor="ctr"/>
-          <a:lstStyle/>
-          <a:p>
-            <a:pPr algn="l">
-              <a:spcBef>
-                <a:spcPts val="0"/>
-              </a:spcBef>
-              <a:spcAft>
-                <a:spcPts val="0"/>
-              </a:spcAft>
-            </a:pPr>
-            <a:r>
               <a:rPr sz="1300" b="1" i="0">
                 <a:solidFill>
                   <a:srgbClr val="5C6870"/>
@@ -9641,93 +9413,6 @@
       <p:sp>
         <p:nvSpPr>
           <p:cNvPr id="20" name="Rounded Rectangle 19"/>
-          <p:cNvSpPr/>
-          <p:nvPr/>
-        </p:nvSpPr>
-        <p:spPr>
-          <a:xfrm>
-            <a:off x="10195560" y="2523744"/>
-            <a:ext cx="1298448" cy="384048"/>
-          </a:xfrm>
-          <a:prstGeom prst="roundRect">
-            <a:avLst>
-              <a:gd name="adj" fmla="val 40000"/>
-            </a:avLst>
-          </a:prstGeom>
-          <a:solidFill>
-            <a:srgbClr val="E06A2C"/>
-          </a:solidFill>
-          <a:ln>
-            <a:noFill/>
-          </a:ln>
-        </p:spPr>
-        <p:style>
-          <a:lnRef idx="1">
-            <a:schemeClr val="accent1"/>
-          </a:lnRef>
-          <a:fillRef idx="3">
-            <a:schemeClr val="accent1"/>
-          </a:fillRef>
-          <a:effectRef idx="2">
-            <a:schemeClr val="accent1"/>
-          </a:effectRef>
-          <a:fontRef idx="minor">
-            <a:schemeClr val="lt1"/>
-          </a:fontRef>
-        </p:style>
-        <p:txBody>
-          <a:bodyPr rtlCol="0" anchor="ctr"/>
-          <a:lstStyle/>
-          <a:p>
-            <a:pPr algn="ctr"/>
-          </a:p>
-        </p:txBody>
-      </p:sp>
-      <p:sp>
-        <p:nvSpPr>
-          <p:cNvPr id="21" name="TextBox 20"/>
-          <p:cNvSpPr txBox="1"/>
-          <p:nvPr/>
-        </p:nvSpPr>
-        <p:spPr>
-          <a:xfrm>
-            <a:off x="10195560" y="2523744"/>
-            <a:ext cx="1298448" cy="384048"/>
-          </a:xfrm>
-          <a:prstGeom prst="rect">
-            <a:avLst/>
-          </a:prstGeom>
-          <a:noFill/>
-        </p:spPr>
-        <p:txBody>
-          <a:bodyPr wrap="square" anchor="ctr"/>
-          <a:lstStyle/>
-          <a:p>
-            <a:pPr algn="ctr">
-              <a:spcBef>
-                <a:spcPts val="0"/>
-              </a:spcBef>
-              <a:spcAft>
-                <a:spcPts val="0"/>
-              </a:spcAft>
-            </a:pPr>
-            <a:r>
-              <a:rPr sz="1300" b="1" i="0">
-                <a:solidFill>
-                  <a:srgbClr val="FFFFFF"/>
-                </a:solidFill>
-                <a:latin typeface="Malgun Gothic"/>
-                <a:ea typeface="Malgun Gothic"/>
-                <a:cs typeface="Malgun Gothic"/>
-              </a:rPr>
-              <a:t>API</a:t>
-            </a:r>
-          </a:p>
-        </p:txBody>
-      </p:sp>
-      <p:sp>
-        <p:nvSpPr>
-          <p:cNvPr id="22" name="Rounded Rectangle 21"/>
           <p:cNvSpPr/>
           <p:nvPr/>
         </p:nvSpPr>
@@ -9774,7 +9459,7 @@
       </p:sp>
       <p:sp>
         <p:nvSpPr>
-          <p:cNvPr id="23" name="Rectangle 22"/>
+          <p:cNvPr id="21" name="Rectangle 20"/>
           <p:cNvSpPr/>
           <p:nvPr/>
         </p:nvSpPr>
@@ -9817,7 +9502,7 @@
       </p:sp>
       <p:sp>
         <p:nvSpPr>
-          <p:cNvPr id="24" name="TextBox 23"/>
+          <p:cNvPr id="22" name="TextBox 21"/>
           <p:cNvSpPr txBox="1"/>
           <p:nvPr/>
         </p:nvSpPr>
@@ -9859,14 +9544,98 @@
       </p:sp>
       <p:sp>
         <p:nvSpPr>
+          <p:cNvPr id="23" name="TextBox 22"/>
+          <p:cNvSpPr txBox="1"/>
+          <p:nvPr/>
+        </p:nvSpPr>
+        <p:spPr>
+          <a:xfrm>
+            <a:off x="1325880" y="3364991"/>
+            <a:ext cx="7680960" cy="347472"/>
+          </a:xfrm>
+          <a:prstGeom prst="rect">
+            <a:avLst/>
+          </a:prstGeom>
+          <a:noFill/>
+        </p:spPr>
+        <p:txBody>
+          <a:bodyPr wrap="square" anchor="ctr"/>
+          <a:lstStyle/>
+          <a:p>
+            <a:pPr algn="l">
+              <a:spcBef>
+                <a:spcPts val="0"/>
+              </a:spcBef>
+              <a:spcAft>
+                <a:spcPts val="0"/>
+              </a:spcAft>
+            </a:pPr>
+            <a:r>
+              <a:rPr sz="2000" b="1" i="0">
+                <a:solidFill>
+                  <a:srgbClr val="1B2E3C"/>
+                </a:solidFill>
+                <a:latin typeface="Malgun Gothic"/>
+                <a:ea typeface="Malgun Gothic"/>
+                <a:cs typeface="Malgun Gothic"/>
+              </a:rPr>
+              <a:t>중고 장터</a:t>
+            </a:r>
+          </a:p>
+        </p:txBody>
+      </p:sp>
+      <p:sp>
+        <p:nvSpPr>
+          <p:cNvPr id="24" name="TextBox 23"/>
+          <p:cNvSpPr txBox="1"/>
+          <p:nvPr/>
+        </p:nvSpPr>
+        <p:spPr>
+          <a:xfrm>
+            <a:off x="9418320" y="3364991"/>
+            <a:ext cx="2057400" cy="347472"/>
+          </a:xfrm>
+          <a:prstGeom prst="rect">
+            <a:avLst/>
+          </a:prstGeom>
+          <a:noFill/>
+        </p:spPr>
+        <p:txBody>
+          <a:bodyPr wrap="square" anchor="ctr"/>
+          <a:lstStyle/>
+          <a:p>
+            <a:pPr algn="r">
+              <a:spcBef>
+                <a:spcPts val="0"/>
+              </a:spcBef>
+              <a:spcAft>
+                <a:spcPts val="0"/>
+              </a:spcAft>
+            </a:pPr>
+            <a:r>
+              <a:rPr sz="1400" b="1" i="0">
+                <a:solidFill>
+                  <a:srgbClr val="2A4C78"/>
+                </a:solidFill>
+                <a:latin typeface="Malgun Gothic"/>
+                <a:ea typeface="Malgun Gothic"/>
+                <a:cs typeface="Malgun Gothic"/>
+              </a:rPr>
+              <a:t>어려움</a:t>
+            </a:r>
+          </a:p>
+        </p:txBody>
+      </p:sp>
+      <p:sp>
+        <p:nvSpPr>
           <p:cNvPr id="25" name="TextBox 24"/>
           <p:cNvSpPr txBox="1"/>
           <p:nvPr/>
         </p:nvSpPr>
         <p:spPr>
           <a:xfrm>
-            <a:off x="1325880" y="3364991"/>
-            <a:ext cx="6035040" cy="347472"/>
+            <a:off x="1325880" y="3694176"/>
+            <a:ext cx="10058400" cy="256032"/>
           </a:xfrm>
           <a:prstGeom prst="rect">
             <a:avLst/>
@@ -9886,15 +9655,15 @@
               </a:spcAft>
             </a:pPr>
             <a:r>
-              <a:rPr sz="2000" b="1" i="0">
-                <a:solidFill>
-                  <a:srgbClr val="1B2E3C"/>
-                </a:solidFill>
-                <a:latin typeface="Malgun Gothic"/>
-                <a:ea typeface="Malgun Gothic"/>
-                <a:cs typeface="Malgun Gothic"/>
-              </a:rPr>
-              <a:t>중고 장터</a:t>
+              <a:rPr sz="1300" b="0" i="0">
+                <a:solidFill>
+                  <a:srgbClr val="1C2830"/>
+                </a:solidFill>
+                <a:latin typeface="Malgun Gothic"/>
+                <a:ea typeface="Malgun Gothic"/>
+                <a:cs typeface="Malgun Gothic"/>
+              </a:rPr>
+              <a:t>파는 회원과 사는 회원이 둘 다 있습니다.</a:t>
             </a:r>
           </a:p>
         </p:txBody>
@@ -9907,8 +9676,8 @@
         </p:nvSpPr>
         <p:spPr>
           <a:xfrm>
-            <a:off x="1325880" y="3694176"/>
-            <a:ext cx="7589520" cy="256032"/>
+            <a:off x="1325880" y="3931920"/>
+            <a:ext cx="10058400" cy="256032"/>
           </a:xfrm>
           <a:prstGeom prst="rect">
             <a:avLst/>
@@ -9928,48 +9697,6 @@
               </a:spcAft>
             </a:pPr>
             <a:r>
-              <a:rPr sz="1300" b="0" i="0">
-                <a:solidFill>
-                  <a:srgbClr val="1C2830"/>
-                </a:solidFill>
-                <a:latin typeface="Malgun Gothic"/>
-                <a:ea typeface="Malgun Gothic"/>
-                <a:cs typeface="Malgun Gothic"/>
-              </a:rPr>
-              <a:t>파는 회원과 사는 회원이 둘 다 있습니다.</a:t>
-            </a:r>
-          </a:p>
-        </p:txBody>
-      </p:sp>
-      <p:sp>
-        <p:nvSpPr>
-          <p:cNvPr id="27" name="TextBox 26"/>
-          <p:cNvSpPr txBox="1"/>
-          <p:nvPr/>
-        </p:nvSpPr>
-        <p:spPr>
-          <a:xfrm>
-            <a:off x="1325880" y="3931920"/>
-            <a:ext cx="7772400" cy="256032"/>
-          </a:xfrm>
-          <a:prstGeom prst="rect">
-            <a:avLst/>
-          </a:prstGeom>
-          <a:noFill/>
-        </p:spPr>
-        <p:txBody>
-          <a:bodyPr wrap="square" anchor="ctr"/>
-          <a:lstStyle/>
-          <a:p>
-            <a:pPr algn="l">
-              <a:spcBef>
-                <a:spcPts val="0"/>
-              </a:spcBef>
-              <a:spcAft>
-                <a:spcPts val="0"/>
-              </a:spcAft>
-            </a:pPr>
-            <a:r>
               <a:rPr sz="1300" b="1" i="0">
                 <a:solidFill>
                   <a:srgbClr val="5C6870"/>
@@ -9985,94 +9712,7 @@
       </p:sp>
       <p:sp>
         <p:nvSpPr>
-          <p:cNvPr id="28" name="Rounded Rectangle 27"/>
-          <p:cNvSpPr/>
-          <p:nvPr/>
-        </p:nvSpPr>
-        <p:spPr>
-          <a:xfrm>
-            <a:off x="10195560" y="3566159"/>
-            <a:ext cx="1298448" cy="384048"/>
-          </a:xfrm>
-          <a:prstGeom prst="roundRect">
-            <a:avLst>
-              <a:gd name="adj" fmla="val 40000"/>
-            </a:avLst>
-          </a:prstGeom>
-          <a:solidFill>
-            <a:srgbClr val="2A4C78"/>
-          </a:solidFill>
-          <a:ln>
-            <a:noFill/>
-          </a:ln>
-        </p:spPr>
-        <p:style>
-          <a:lnRef idx="1">
-            <a:schemeClr val="accent1"/>
-          </a:lnRef>
-          <a:fillRef idx="3">
-            <a:schemeClr val="accent1"/>
-          </a:fillRef>
-          <a:effectRef idx="2">
-            <a:schemeClr val="accent1"/>
-          </a:effectRef>
-          <a:fontRef idx="minor">
-            <a:schemeClr val="lt1"/>
-          </a:fontRef>
-        </p:style>
-        <p:txBody>
-          <a:bodyPr rtlCol="0" anchor="ctr"/>
-          <a:lstStyle/>
-          <a:p>
-            <a:pPr algn="ctr"/>
-          </a:p>
-        </p:txBody>
-      </p:sp>
-      <p:sp>
-        <p:nvSpPr>
-          <p:cNvPr id="29" name="TextBox 28"/>
-          <p:cNvSpPr txBox="1"/>
-          <p:nvPr/>
-        </p:nvSpPr>
-        <p:spPr>
-          <a:xfrm>
-            <a:off x="10195560" y="3566159"/>
-            <a:ext cx="1298448" cy="384048"/>
-          </a:xfrm>
-          <a:prstGeom prst="rect">
-            <a:avLst/>
-          </a:prstGeom>
-          <a:noFill/>
-        </p:spPr>
-        <p:txBody>
-          <a:bodyPr wrap="square" anchor="ctr"/>
-          <a:lstStyle/>
-          <a:p>
-            <a:pPr algn="ctr">
-              <a:spcBef>
-                <a:spcPts val="0"/>
-              </a:spcBef>
-              <a:spcAft>
-                <a:spcPts val="0"/>
-              </a:spcAft>
-            </a:pPr>
-            <a:r>
-              <a:rPr sz="1300" b="1" i="0">
-                <a:solidFill>
-                  <a:srgbClr val="FFFFFF"/>
-                </a:solidFill>
-                <a:latin typeface="Malgun Gothic"/>
-                <a:ea typeface="Malgun Gothic"/>
-                <a:cs typeface="Malgun Gothic"/>
-              </a:rPr>
-              <a:t>JPA</a:t>
-            </a:r>
-          </a:p>
-        </p:txBody>
-      </p:sp>
-      <p:sp>
-        <p:nvSpPr>
-          <p:cNvPr id="30" name="Rounded Rectangle 29"/>
+          <p:cNvPr id="27" name="Rounded Rectangle 26"/>
           <p:cNvSpPr/>
           <p:nvPr/>
         </p:nvSpPr>
@@ -10119,7 +9759,7 @@
       </p:sp>
       <p:sp>
         <p:nvSpPr>
-          <p:cNvPr id="31" name="Rectangle 30"/>
+          <p:cNvPr id="28" name="Rectangle 27"/>
           <p:cNvSpPr/>
           <p:nvPr/>
         </p:nvSpPr>
@@ -10162,7 +9802,7 @@
       </p:sp>
       <p:sp>
         <p:nvSpPr>
-          <p:cNvPr id="32" name="TextBox 31"/>
+          <p:cNvPr id="29" name="TextBox 28"/>
           <p:cNvSpPr txBox="1"/>
           <p:nvPr/>
         </p:nvSpPr>
@@ -10204,14 +9844,140 @@
       </p:sp>
       <p:sp>
         <p:nvSpPr>
+          <p:cNvPr id="30" name="TextBox 29"/>
+          <p:cNvSpPr txBox="1"/>
+          <p:nvPr/>
+        </p:nvSpPr>
+        <p:spPr>
+          <a:xfrm>
+            <a:off x="1325880" y="4407407"/>
+            <a:ext cx="7680960" cy="347472"/>
+          </a:xfrm>
+          <a:prstGeom prst="rect">
+            <a:avLst/>
+          </a:prstGeom>
+          <a:noFill/>
+        </p:spPr>
+        <p:txBody>
+          <a:bodyPr wrap="square" anchor="ctr"/>
+          <a:lstStyle/>
+          <a:p>
+            <a:pPr algn="l">
+              <a:spcBef>
+                <a:spcPts val="0"/>
+              </a:spcBef>
+              <a:spcAft>
+                <a:spcPts val="0"/>
+              </a:spcAft>
+            </a:pPr>
+            <a:r>
+              <a:rPr sz="2000" b="1" i="0">
+                <a:solidFill>
+                  <a:srgbClr val="1B2E3C"/>
+                </a:solidFill>
+                <a:latin typeface="Malgun Gothic"/>
+                <a:ea typeface="Malgun Gothic"/>
+                <a:cs typeface="Malgun Gothic"/>
+              </a:rPr>
+              <a:t>스터디카페</a:t>
+            </a:r>
+          </a:p>
+        </p:txBody>
+      </p:sp>
+      <p:sp>
+        <p:nvSpPr>
+          <p:cNvPr id="31" name="TextBox 30"/>
+          <p:cNvSpPr txBox="1"/>
+          <p:nvPr/>
+        </p:nvSpPr>
+        <p:spPr>
+          <a:xfrm>
+            <a:off x="9418320" y="4407407"/>
+            <a:ext cx="2057400" cy="347472"/>
+          </a:xfrm>
+          <a:prstGeom prst="rect">
+            <a:avLst/>
+          </a:prstGeom>
+          <a:noFill/>
+        </p:spPr>
+        <p:txBody>
+          <a:bodyPr wrap="square" anchor="ctr"/>
+          <a:lstStyle/>
+          <a:p>
+            <a:pPr algn="r">
+              <a:spcBef>
+                <a:spcPts val="0"/>
+              </a:spcBef>
+              <a:spcAft>
+                <a:spcPts val="0"/>
+              </a:spcAft>
+            </a:pPr>
+            <a:r>
+              <a:rPr sz="1400" b="1" i="0">
+                <a:solidFill>
+                  <a:srgbClr val="2A4C78"/>
+                </a:solidFill>
+                <a:latin typeface="Malgun Gothic"/>
+                <a:ea typeface="Malgun Gothic"/>
+                <a:cs typeface="Malgun Gothic"/>
+              </a:rPr>
+              <a:t>어려움</a:t>
+            </a:r>
+          </a:p>
+        </p:txBody>
+      </p:sp>
+      <p:sp>
+        <p:nvSpPr>
+          <p:cNvPr id="32" name="TextBox 31"/>
+          <p:cNvSpPr txBox="1"/>
+          <p:nvPr/>
+        </p:nvSpPr>
+        <p:spPr>
+          <a:xfrm>
+            <a:off x="1325880" y="4736592"/>
+            <a:ext cx="10058400" cy="256032"/>
+          </a:xfrm>
+          <a:prstGeom prst="rect">
+            <a:avLst/>
+          </a:prstGeom>
+          <a:noFill/>
+        </p:spPr>
+        <p:txBody>
+          <a:bodyPr wrap="square" anchor="ctr"/>
+          <a:lstStyle/>
+          <a:p>
+            <a:pPr algn="l">
+              <a:spcBef>
+                <a:spcPts val="0"/>
+              </a:spcBef>
+              <a:spcAft>
+                <a:spcPts val="0"/>
+              </a:spcAft>
+            </a:pPr>
+            <a:r>
+              <a:rPr sz="1300" b="0" i="0">
+                <a:solidFill>
+                  <a:srgbClr val="1C2830"/>
+                </a:solidFill>
+                <a:latin typeface="Malgun Gothic"/>
+                <a:ea typeface="Malgun Gothic"/>
+                <a:cs typeface="Malgun Gothic"/>
+              </a:rPr>
+              <a:t>같은 좌석, 같은 시간은 한 명만 됩니다.</a:t>
+            </a:r>
+          </a:p>
+        </p:txBody>
+      </p:sp>
+      <p:sp>
+        <p:nvSpPr>
           <p:cNvPr id="33" name="TextBox 32"/>
           <p:cNvSpPr txBox="1"/>
           <p:nvPr/>
         </p:nvSpPr>
         <p:spPr>
           <a:xfrm>
-            <a:off x="1325880" y="4407407"/>
-            <a:ext cx="6035040" cy="347472"/>
+            <a:off x="1325880" y="4974336"/>
+            <a:ext cx="10058400" cy="256032"/>
           </a:xfrm>
           <a:prstGeom prst="rect">
             <a:avLst/>
@@ -10231,90 +9997,6 @@
               </a:spcAft>
             </a:pPr>
             <a:r>
-              <a:rPr sz="2000" b="1" i="0">
-                <a:solidFill>
-                  <a:srgbClr val="1B2E3C"/>
-                </a:solidFill>
-                <a:latin typeface="Malgun Gothic"/>
-                <a:ea typeface="Malgun Gothic"/>
-                <a:cs typeface="Malgun Gothic"/>
-              </a:rPr>
-              <a:t>스터디카페</a:t>
-            </a:r>
-          </a:p>
-        </p:txBody>
-      </p:sp>
-      <p:sp>
-        <p:nvSpPr>
-          <p:cNvPr id="34" name="TextBox 33"/>
-          <p:cNvSpPr txBox="1"/>
-          <p:nvPr/>
-        </p:nvSpPr>
-        <p:spPr>
-          <a:xfrm>
-            <a:off x="1325880" y="4736592"/>
-            <a:ext cx="7589520" cy="256032"/>
-          </a:xfrm>
-          <a:prstGeom prst="rect">
-            <a:avLst/>
-          </a:prstGeom>
-          <a:noFill/>
-        </p:spPr>
-        <p:txBody>
-          <a:bodyPr wrap="square" anchor="ctr"/>
-          <a:lstStyle/>
-          <a:p>
-            <a:pPr algn="l">
-              <a:spcBef>
-                <a:spcPts val="0"/>
-              </a:spcBef>
-              <a:spcAft>
-                <a:spcPts val="0"/>
-              </a:spcAft>
-            </a:pPr>
-            <a:r>
-              <a:rPr sz="1300" b="0" i="0">
-                <a:solidFill>
-                  <a:srgbClr val="1C2830"/>
-                </a:solidFill>
-                <a:latin typeface="Malgun Gothic"/>
-                <a:ea typeface="Malgun Gothic"/>
-                <a:cs typeface="Malgun Gothic"/>
-              </a:rPr>
-              <a:t>같은 좌석, 같은 시간은 한 명만 됩니다.</a:t>
-            </a:r>
-          </a:p>
-        </p:txBody>
-      </p:sp>
-      <p:sp>
-        <p:nvSpPr>
-          <p:cNvPr id="35" name="TextBox 34"/>
-          <p:cNvSpPr txBox="1"/>
-          <p:nvPr/>
-        </p:nvSpPr>
-        <p:spPr>
-          <a:xfrm>
-            <a:off x="1325880" y="4974336"/>
-            <a:ext cx="7772400" cy="256032"/>
-          </a:xfrm>
-          <a:prstGeom prst="rect">
-            <a:avLst/>
-          </a:prstGeom>
-          <a:noFill/>
-        </p:spPr>
-        <p:txBody>
-          <a:bodyPr wrap="square" anchor="ctr"/>
-          <a:lstStyle/>
-          <a:p>
-            <a:pPr algn="l">
-              <a:spcBef>
-                <a:spcPts val="0"/>
-              </a:spcBef>
-              <a:spcAft>
-                <a:spcPts val="0"/>
-              </a:spcAft>
-            </a:pPr>
-            <a:r>
               <a:rPr sz="1300" b="1" i="0">
                 <a:solidFill>
                   <a:srgbClr val="5C6870"/>
@@ -10330,94 +10012,7 @@
       </p:sp>
       <p:sp>
         <p:nvSpPr>
-          <p:cNvPr id="36" name="Rounded Rectangle 35"/>
-          <p:cNvSpPr/>
-          <p:nvPr/>
-        </p:nvSpPr>
-        <p:spPr>
-          <a:xfrm>
-            <a:off x="10195560" y="4608575"/>
-            <a:ext cx="1298448" cy="384048"/>
-          </a:xfrm>
-          <a:prstGeom prst="roundRect">
-            <a:avLst>
-              <a:gd name="adj" fmla="val 40000"/>
-            </a:avLst>
-          </a:prstGeom>
-          <a:solidFill>
-            <a:srgbClr val="2A4C78"/>
-          </a:solidFill>
-          <a:ln>
-            <a:noFill/>
-          </a:ln>
-        </p:spPr>
-        <p:style>
-          <a:lnRef idx="1">
-            <a:schemeClr val="accent1"/>
-          </a:lnRef>
-          <a:fillRef idx="3">
-            <a:schemeClr val="accent1"/>
-          </a:fillRef>
-          <a:effectRef idx="2">
-            <a:schemeClr val="accent1"/>
-          </a:effectRef>
-          <a:fontRef idx="minor">
-            <a:schemeClr val="lt1"/>
-          </a:fontRef>
-        </p:style>
-        <p:txBody>
-          <a:bodyPr rtlCol="0" anchor="ctr"/>
-          <a:lstStyle/>
-          <a:p>
-            <a:pPr algn="ctr"/>
-          </a:p>
-        </p:txBody>
-      </p:sp>
-      <p:sp>
-        <p:nvSpPr>
-          <p:cNvPr id="37" name="TextBox 36"/>
-          <p:cNvSpPr txBox="1"/>
-          <p:nvPr/>
-        </p:nvSpPr>
-        <p:spPr>
-          <a:xfrm>
-            <a:off x="10195560" y="4608575"/>
-            <a:ext cx="1298448" cy="384048"/>
-          </a:xfrm>
-          <a:prstGeom prst="rect">
-            <a:avLst/>
-          </a:prstGeom>
-          <a:noFill/>
-        </p:spPr>
-        <p:txBody>
-          <a:bodyPr wrap="square" anchor="ctr"/>
-          <a:lstStyle/>
-          <a:p>
-            <a:pPr algn="ctr">
-              <a:spcBef>
-                <a:spcPts val="0"/>
-              </a:spcBef>
-              <a:spcAft>
-                <a:spcPts val="0"/>
-              </a:spcAft>
-            </a:pPr>
-            <a:r>
-              <a:rPr sz="1300" b="1" i="0">
-                <a:solidFill>
-                  <a:srgbClr val="FFFFFF"/>
-                </a:solidFill>
-                <a:latin typeface="Malgun Gothic"/>
-                <a:ea typeface="Malgun Gothic"/>
-                <a:cs typeface="Malgun Gothic"/>
-              </a:rPr>
-              <a:t>MyBatis</a:t>
-            </a:r>
-          </a:p>
-        </p:txBody>
-      </p:sp>
-      <p:sp>
-        <p:nvSpPr>
-          <p:cNvPr id="38" name="Rounded Rectangle 37"/>
+          <p:cNvPr id="34" name="Rounded Rectangle 33"/>
           <p:cNvSpPr/>
           <p:nvPr/>
         </p:nvSpPr>
@@ -10464,7 +10059,7 @@
       </p:sp>
       <p:sp>
         <p:nvSpPr>
-          <p:cNvPr id="39" name="Rectangle 38"/>
+          <p:cNvPr id="35" name="Rectangle 34"/>
           <p:cNvSpPr/>
           <p:nvPr/>
         </p:nvSpPr>
@@ -10507,7 +10102,7 @@
       </p:sp>
       <p:sp>
         <p:nvSpPr>
-          <p:cNvPr id="40" name="TextBox 39"/>
+          <p:cNvPr id="36" name="TextBox 35"/>
           <p:cNvSpPr txBox="1"/>
           <p:nvPr/>
         </p:nvSpPr>
@@ -10549,220 +10144,175 @@
       </p:sp>
       <p:sp>
         <p:nvSpPr>
+          <p:cNvPr id="37" name="TextBox 36"/>
+          <p:cNvSpPr txBox="1"/>
+          <p:nvPr/>
+        </p:nvSpPr>
+        <p:spPr>
+          <a:xfrm>
+            <a:off x="1325880" y="5449823"/>
+            <a:ext cx="7680960" cy="347472"/>
+          </a:xfrm>
+          <a:prstGeom prst="rect">
+            <a:avLst/>
+          </a:prstGeom>
+          <a:noFill/>
+        </p:spPr>
+        <p:txBody>
+          <a:bodyPr wrap="square" anchor="ctr"/>
+          <a:lstStyle/>
+          <a:p>
+            <a:pPr algn="l">
+              <a:spcBef>
+                <a:spcPts val="0"/>
+              </a:spcBef>
+              <a:spcAft>
+                <a:spcPts val="0"/>
+              </a:spcAft>
+            </a:pPr>
+            <a:r>
+              <a:rPr sz="2000" b="1" i="0">
+                <a:solidFill>
+                  <a:srgbClr val="1B2E3C"/>
+                </a:solidFill>
+                <a:latin typeface="Malgun Gothic"/>
+                <a:ea typeface="Malgun Gothic"/>
+                <a:cs typeface="Malgun Gothic"/>
+              </a:rPr>
+              <a:t>영화 예매</a:t>
+            </a:r>
+          </a:p>
+        </p:txBody>
+      </p:sp>
+      <p:sp>
+        <p:nvSpPr>
+          <p:cNvPr id="38" name="TextBox 37"/>
+          <p:cNvSpPr txBox="1"/>
+          <p:nvPr/>
+        </p:nvSpPr>
+        <p:spPr>
+          <a:xfrm>
+            <a:off x="9418320" y="5449823"/>
+            <a:ext cx="2057400" cy="347472"/>
+          </a:xfrm>
+          <a:prstGeom prst="rect">
+            <a:avLst/>
+          </a:prstGeom>
+          <a:noFill/>
+        </p:spPr>
+        <p:txBody>
+          <a:bodyPr wrap="square" anchor="ctr"/>
+          <a:lstStyle/>
+          <a:p>
+            <a:pPr algn="r">
+              <a:spcBef>
+                <a:spcPts val="0"/>
+              </a:spcBef>
+              <a:spcAft>
+                <a:spcPts val="0"/>
+              </a:spcAft>
+            </a:pPr>
+            <a:r>
+              <a:rPr sz="1400" b="1" i="0">
+                <a:solidFill>
+                  <a:srgbClr val="2A4C78"/>
+                </a:solidFill>
+                <a:latin typeface="Malgun Gothic"/>
+                <a:ea typeface="Malgun Gothic"/>
+                <a:cs typeface="Malgun Gothic"/>
+              </a:rPr>
+              <a:t>어려움</a:t>
+            </a:r>
+          </a:p>
+        </p:txBody>
+      </p:sp>
+      <p:sp>
+        <p:nvSpPr>
+          <p:cNvPr id="39" name="TextBox 38"/>
+          <p:cNvSpPr txBox="1"/>
+          <p:nvPr/>
+        </p:nvSpPr>
+        <p:spPr>
+          <a:xfrm>
+            <a:off x="1325880" y="5779007"/>
+            <a:ext cx="10058400" cy="256032"/>
+          </a:xfrm>
+          <a:prstGeom prst="rect">
+            <a:avLst/>
+          </a:prstGeom>
+          <a:noFill/>
+        </p:spPr>
+        <p:txBody>
+          <a:bodyPr wrap="square" anchor="ctr"/>
+          <a:lstStyle/>
+          <a:p>
+            <a:pPr algn="l">
+              <a:spcBef>
+                <a:spcPts val="0"/>
+              </a:spcBef>
+              <a:spcAft>
+                <a:spcPts val="0"/>
+              </a:spcAft>
+            </a:pPr>
+            <a:r>
+              <a:rPr sz="1300" b="0" i="0">
+                <a:solidFill>
+                  <a:srgbClr val="1C2830"/>
+                </a:solidFill>
+                <a:latin typeface="Malgun Gothic"/>
+                <a:ea typeface="Malgun Gothic"/>
+                <a:cs typeface="Malgun Gothic"/>
+              </a:rPr>
+              <a:t>영화, 상영시간, 좌석이 한꺼번에 연결됩니다.</a:t>
+            </a:r>
+          </a:p>
+        </p:txBody>
+      </p:sp>
+      <p:sp>
+        <p:nvSpPr>
+          <p:cNvPr id="40" name="TextBox 39"/>
+          <p:cNvSpPr txBox="1"/>
+          <p:nvPr/>
+        </p:nvSpPr>
+        <p:spPr>
+          <a:xfrm>
+            <a:off x="1325880" y="6016751"/>
+            <a:ext cx="10058400" cy="256032"/>
+          </a:xfrm>
+          <a:prstGeom prst="rect">
+            <a:avLst/>
+          </a:prstGeom>
+          <a:noFill/>
+        </p:spPr>
+        <p:txBody>
+          <a:bodyPr wrap="square" anchor="ctr"/>
+          <a:lstStyle/>
+          <a:p>
+            <a:pPr algn="l">
+              <a:spcBef>
+                <a:spcPts val="0"/>
+              </a:spcBef>
+              <a:spcAft>
+                <a:spcPts val="0"/>
+              </a:spcAft>
+            </a:pPr>
+            <a:r>
+              <a:rPr sz="1300" b="1" i="0">
+                <a:solidFill>
+                  <a:srgbClr val="5C6870"/>
+                </a:solidFill>
+                <a:latin typeface="Malgun Gothic"/>
+                <a:ea typeface="Malgun Gothic"/>
+                <a:cs typeface="Malgun Gothic"/>
+              </a:rPr>
+              <a:t>A 회원   B 영화   C 예매   D 관리자</a:t>
+            </a:r>
+          </a:p>
+        </p:txBody>
+      </p:sp>
+      <p:sp>
+        <p:nvSpPr>
           <p:cNvPr id="41" name="TextBox 40"/>
-          <p:cNvSpPr txBox="1"/>
-          <p:nvPr/>
-        </p:nvSpPr>
-        <p:spPr>
-          <a:xfrm>
-            <a:off x="1325880" y="5449823"/>
-            <a:ext cx="6035040" cy="347472"/>
-          </a:xfrm>
-          <a:prstGeom prst="rect">
-            <a:avLst/>
-          </a:prstGeom>
-          <a:noFill/>
-        </p:spPr>
-        <p:txBody>
-          <a:bodyPr wrap="square" anchor="ctr"/>
-          <a:lstStyle/>
-          <a:p>
-            <a:pPr algn="l">
-              <a:spcBef>
-                <a:spcPts val="0"/>
-              </a:spcBef>
-              <a:spcAft>
-                <a:spcPts val="0"/>
-              </a:spcAft>
-            </a:pPr>
-            <a:r>
-              <a:rPr sz="2000" b="1" i="0">
-                <a:solidFill>
-                  <a:srgbClr val="1B2E3C"/>
-                </a:solidFill>
-                <a:latin typeface="Malgun Gothic"/>
-                <a:ea typeface="Malgun Gothic"/>
-                <a:cs typeface="Malgun Gothic"/>
-              </a:rPr>
-              <a:t>영화 예매</a:t>
-            </a:r>
-          </a:p>
-        </p:txBody>
-      </p:sp>
-      <p:sp>
-        <p:nvSpPr>
-          <p:cNvPr id="42" name="TextBox 41"/>
-          <p:cNvSpPr txBox="1"/>
-          <p:nvPr/>
-        </p:nvSpPr>
-        <p:spPr>
-          <a:xfrm>
-            <a:off x="1325880" y="5779007"/>
-            <a:ext cx="7589520" cy="256032"/>
-          </a:xfrm>
-          <a:prstGeom prst="rect">
-            <a:avLst/>
-          </a:prstGeom>
-          <a:noFill/>
-        </p:spPr>
-        <p:txBody>
-          <a:bodyPr wrap="square" anchor="ctr"/>
-          <a:lstStyle/>
-          <a:p>
-            <a:pPr algn="l">
-              <a:spcBef>
-                <a:spcPts val="0"/>
-              </a:spcBef>
-              <a:spcAft>
-                <a:spcPts val="0"/>
-              </a:spcAft>
-            </a:pPr>
-            <a:r>
-              <a:rPr sz="1300" b="0" i="0">
-                <a:solidFill>
-                  <a:srgbClr val="1C2830"/>
-                </a:solidFill>
-                <a:latin typeface="Malgun Gothic"/>
-                <a:ea typeface="Malgun Gothic"/>
-                <a:cs typeface="Malgun Gothic"/>
-              </a:rPr>
-              <a:t>영화, 상영시간, 좌석이 한꺼번에 연결됩니다.</a:t>
-            </a:r>
-          </a:p>
-        </p:txBody>
-      </p:sp>
-      <p:sp>
-        <p:nvSpPr>
-          <p:cNvPr id="43" name="TextBox 42"/>
-          <p:cNvSpPr txBox="1"/>
-          <p:nvPr/>
-        </p:nvSpPr>
-        <p:spPr>
-          <a:xfrm>
-            <a:off x="1325880" y="6016751"/>
-            <a:ext cx="7772400" cy="256032"/>
-          </a:xfrm>
-          <a:prstGeom prst="rect">
-            <a:avLst/>
-          </a:prstGeom>
-          <a:noFill/>
-        </p:spPr>
-        <p:txBody>
-          <a:bodyPr wrap="square" anchor="ctr"/>
-          <a:lstStyle/>
-          <a:p>
-            <a:pPr algn="l">
-              <a:spcBef>
-                <a:spcPts val="0"/>
-              </a:spcBef>
-              <a:spcAft>
-                <a:spcPts val="0"/>
-              </a:spcAft>
-            </a:pPr>
-            <a:r>
-              <a:rPr sz="1300" b="1" i="0">
-                <a:solidFill>
-                  <a:srgbClr val="5C6870"/>
-                </a:solidFill>
-                <a:latin typeface="Malgun Gothic"/>
-                <a:ea typeface="Malgun Gothic"/>
-                <a:cs typeface="Malgun Gothic"/>
-              </a:rPr>
-              <a:t>A 회원   B 영화   C 예매   D 관리자</a:t>
-            </a:r>
-          </a:p>
-        </p:txBody>
-      </p:sp>
-      <p:sp>
-        <p:nvSpPr>
-          <p:cNvPr id="44" name="Rounded Rectangle 43"/>
-          <p:cNvSpPr/>
-          <p:nvPr/>
-        </p:nvSpPr>
-        <p:spPr>
-          <a:xfrm>
-            <a:off x="10195560" y="5650991"/>
-            <a:ext cx="1298448" cy="384048"/>
-          </a:xfrm>
-          <a:prstGeom prst="roundRect">
-            <a:avLst>
-              <a:gd name="adj" fmla="val 40000"/>
-            </a:avLst>
-          </a:prstGeom>
-          <a:solidFill>
-            <a:srgbClr val="2A4C78"/>
-          </a:solidFill>
-          <a:ln>
-            <a:noFill/>
-          </a:ln>
-        </p:spPr>
-        <p:style>
-          <a:lnRef idx="1">
-            <a:schemeClr val="accent1"/>
-          </a:lnRef>
-          <a:fillRef idx="3">
-            <a:schemeClr val="accent1"/>
-          </a:fillRef>
-          <a:effectRef idx="2">
-            <a:schemeClr val="accent1"/>
-          </a:effectRef>
-          <a:fontRef idx="minor">
-            <a:schemeClr val="lt1"/>
-          </a:fontRef>
-        </p:style>
-        <p:txBody>
-          <a:bodyPr rtlCol="0" anchor="ctr"/>
-          <a:lstStyle/>
-          <a:p>
-            <a:pPr algn="ctr"/>
-          </a:p>
-        </p:txBody>
-      </p:sp>
-      <p:sp>
-        <p:nvSpPr>
-          <p:cNvPr id="45" name="TextBox 44"/>
-          <p:cNvSpPr txBox="1"/>
-          <p:nvPr/>
-        </p:nvSpPr>
-        <p:spPr>
-          <a:xfrm>
-            <a:off x="10195560" y="5650991"/>
-            <a:ext cx="1298448" cy="384048"/>
-          </a:xfrm>
-          <a:prstGeom prst="rect">
-            <a:avLst/>
-          </a:prstGeom>
-          <a:noFill/>
-        </p:spPr>
-        <p:txBody>
-          <a:bodyPr wrap="square" anchor="ctr"/>
-          <a:lstStyle/>
-          <a:p>
-            <a:pPr algn="ctr">
-              <a:spcBef>
-                <a:spcPts val="0"/>
-              </a:spcBef>
-              <a:spcAft>
-                <a:spcPts val="0"/>
-              </a:spcAft>
-            </a:pPr>
-            <a:r>
-              <a:rPr sz="1300" b="1" i="0">
-                <a:solidFill>
-                  <a:srgbClr val="FFFFFF"/>
-                </a:solidFill>
-                <a:latin typeface="Malgun Gothic"/>
-                <a:ea typeface="Malgun Gothic"/>
-                <a:cs typeface="Malgun Gothic"/>
-              </a:rPr>
-              <a:t>JPA</a:t>
-            </a:r>
-          </a:p>
-        </p:txBody>
-      </p:sp>
-      <p:sp>
-        <p:nvSpPr>
-          <p:cNvPr id="46" name="TextBox 45"/>
           <p:cNvSpPr txBox="1"/>
           <p:nvPr/>
         </p:nvSpPr>
@@ -10804,7 +10354,7 @@
       </p:sp>
       <p:sp>
         <p:nvSpPr>
-          <p:cNvPr id="47" name="TextBox 46"/>
+          <p:cNvPr id="42" name="TextBox 41"/>
           <p:cNvSpPr txBox="1"/>
           <p:nvPr/>
         </p:nvSpPr>

</xml_diff>